<commit_message>
Strip chart text from slides and add a limitations slide
Chart slides now use title-free, annotation-free chart renders (same
underlying analysis, pulled from the pure-code notebook's output) so
the graphs read as pure evidence - the claim lives in the slide title
and speaker notes instead, not baked into the image itself.

Added a new slide 3, "What this analysis can't tell you": five
limitations - cross-sectional snapshot not a trend, administrative
ratings not an independent audit, correlational not causal findings,
one small-sample result (n=8 states) flagged as illustrative, and the
stated modelling choices behind "well-connected" and "non-compliance."
Everything from Problem 1 onward renumbered (20 slides total, up from
19).

Co-Authored-By: Claude Sonnet 5 <noreply@anthropic.com>
Claude-Session: https://claude.ai/code/session_01A4p3xFHs8teR45na59HPSB
</commit_message>
<xml_diff>
--- a/ACECQA_Presentation.pptx
+++ b/ACECQA_Presentation.pptx
@@ -24,9 +24,10 @@
     <p:sldId id="272" r:id="rId18"/>
     <p:sldId id="273" r:id="rId19"/>
     <p:sldId id="274" r:id="rId20"/>
+    <p:sldId id="275" r:id="rId21"/>
   </p:sldIdLst>
   <p:notesMasterIdLst>
-    <p:notesMasterId r:id="rId21"/>
+    <p:notesMasterId r:id="rId22"/>
   </p:notesMasterIdLst>
   <p:sldSz cx="12192000" cy="6858000"/>
   <p:notesSz cx="6858000" cy="12192000"/>
@@ -608,7 +609,7 @@
           <a:p>
             <a:r>
               <a:rPr lang="en-US" dirty="0"/>
-              <a:t>First: the geographic disparity itself. Measuring services per square kilometre by ABS area type, Major Urban areas have about twelve thousand times the density of Rural Balance areas. That's not just 'cities have more people' — it's an order of magnitude beyond any population ratio you could justify. Provision is structurally concentrated, not just naturally uneven.</a:t>
+              <a:t>Second problem, and the assignment sets four specific questions here. I'm answering each one directly, with a chart built to prove a claim, not just describe a distribution.</a:t>
             </a:r>
             <a:endParaRPr lang="en-US" dirty="0"/>
           </a:p>
@@ -696,7 +697,7 @@
           <a:p>
             <a:r>
               <a:rPr lang="en-US" dirty="0"/>
-              <a:t>Second: where specifically should ACECQA add capacity? I measured, for every service, the distance to its nearest alternative — the real question a family asks when their usual centre is full or closed. Ranked worst first: Western Australia's Bounded Localities are the single worst case in the country, a median forty-one kilometres to a backup option. The Northern Territory's Bounded Localities are second, at thirty kilometres. These are the two places a new-service dollar should go first — not a general 'rural funding' line, a named list.</a:t>
+              <a:t>First: the geographic disparity itself. Measuring services per square kilometre by ABS area type, Major Urban areas have about twelve thousand times the density of Rural Balance areas. That's not just 'cities have more people' — it's an order of magnitude beyond any population ratio you could justify. Provision is structurally concentrated, not just naturally uneven.</a:t>
             </a:r>
             <a:endParaRPr lang="en-US" dirty="0"/>
           </a:p>
@@ -784,7 +785,7 @@
           <a:p>
             <a:r>
               <a:rPr lang="en-US" dirty="0"/>
-              <a:t>One gut check: are NT and Tasmania — already flagged worst on compliance — just showing up again here because they're the most rural? Plotting rural share against statewide connectivity: yes for them, a genuinely statewide problem. But Western Australia breaks the pattern — despite the country's biggest coverage gap, from Chart 7, only four percent of its services are rural, so its statewide connectivity average is actually the best in the country. Same state, two different problems.</a:t>
+              <a:t>Second: where specifically should ACECQA add capacity? I measured, for every service, the distance to its nearest alternative — the real question a family asks when their usual centre is full or closed. Ranked worst first: Western Australia's Bounded Localities are the single worst case in the country, a median forty-one kilometres to a backup option. The Northern Territory's Bounded Localities are second, at thirty kilometres. These are the two places a new-service dollar should go first — not a general 'rural funding' line, a named list.</a:t>
             </a:r>
             <a:endParaRPr lang="en-US" dirty="0"/>
           </a:p>
@@ -872,7 +873,7 @@
           <a:p>
             <a:r>
               <a:rPr lang="en-US" dirty="0"/>
-              <a:t>Third requirement: transport connectivity, using the actual distance-to-station and distance-to-bus-stop fields — with a deliberately generous bar, five kilometres to a train station or ten to a bus stop, a short drive, not a walk. Even so, eighty-three percent of services nationally clear it. But that collapses to twenty-one percent in small country towns and thirty-four in the most rural areas — a seventy-point gap against major cities, on a generous bar. A real rural transport gap, not a threshold artefact.</a:t>
+              <a:t>One gut check: are NT and Tasmania — already flagged worst on compliance — just showing up again here because they're the most rural? Plotting rural share against statewide connectivity: yes for them, a genuinely statewide problem. But Western Australia breaks the pattern — despite the country's biggest coverage gap, from Chart 7, only four percent of its services are rural, so its statewide connectivity average is actually the best in the country. Same state, two different problems.</a:t>
             </a:r>
             <a:endParaRPr lang="en-US" dirty="0"/>
           </a:p>
@@ -960,7 +961,7 @@
           <a:p>
             <a:r>
               <a:rPr lang="en-US" dirty="0"/>
-              <a:t>Fourth: mapping every poorly-connected service directly, rather than just a state or area-type average. Roughly twenty-seven hundred services, in red, more than a short drive from any train or bus stop — concentrated in small towns and rural stretches away from the main rail corridors, not scattered randomly. That confirms Chart 9's area breakdown directly: this is a genuine, geographically concentrated rural access gap.</a:t>
+              <a:t>Third requirement: transport connectivity, using the actual distance-to-station and distance-to-bus-stop fields — with a deliberately generous bar, five kilometres to a train station or ten to a bus stop, a short drive, not a walk. Even so, eighty-three percent of services nationally clear it. But that collapses to twenty-one percent in small country towns and thirty-four in the most rural areas — a seventy-point gap against major cities, on a generous bar. A real rural transport gap, not a threshold artefact.</a:t>
             </a:r>
             <a:endParaRPr lang="en-US" dirty="0"/>
           </a:p>
@@ -1048,7 +1049,7 @@
           <a:p>
             <a:r>
               <a:rPr lang="en-US" dirty="0"/>
-              <a:t>Third problem, and it's a different kind of test. ACECQA could point to three operational levers — size, opening hours, how old a service is — and assume any of them explains non-compliance. I tested all three directly. Two matter. One doesn't.</a:t>
+              <a:t>Fourth: mapping every poorly-connected service directly, rather than just a state or area-type average. Roughly twenty-seven hundred services, in red, more than a short drive from any train or bus stop — concentrated in small towns and rural stretches away from the main rail corridors, not scattered randomly. That confirms Chart 9's area breakdown directly: this is a genuine, geographically concentrated rural access gap.</a:t>
             </a:r>
             <a:endParaRPr lang="en-US" dirty="0"/>
           </a:p>
@@ -1136,7 +1137,7 @@
           <a:p>
             <a:r>
               <a:rPr lang="en-US" dirty="0"/>
-              <a:t>Capacity varies a lot by type and by area — sixty-six places typical in major cities, twenty-seven in small country towns. But tested directly against non-compliance in capacity bands, the smallest services sit at nine-point-three percent, the largest at eight-point-six — not even statistically significant. A bigger centre is no safer bet — a new rural service doesn't need city-sized capacity to meet the standard.</a:t>
+              <a:t>Third problem, and it's a different kind of test. ACECQA could point to three operational levers — size, opening hours, how old a service is — and assume any of them explains non-compliance. I tested all three directly. Two matter. One doesn't.</a:t>
             </a:r>
             <a:endParaRPr lang="en-US" dirty="0"/>
           </a:p>
@@ -1224,7 +1225,7 @@
           <a:p>
             <a:r>
               <a:rPr lang="en-US" dirty="0"/>
-              <a:t>A data trap first: approvals-per-year spikes in 2012 — over four thousand in one year. Read naively, that's explosive growth. It isn't — the National Quality Framework commenced that January and bulk-transferred every already-operating service onto new numbers, not newly opened ones. The right-hand panel is the real story: grouped by when they were actually approved, services from 2019 onward sit at eleven percent non-compliant, against eight-point-four percent for pre-2012, long-established services. Newer services simply haven't had the years to embed practice yet. That's the strongest operational signal in this whole analysis.</a:t>
+              <a:t>Capacity varies a lot by type and by area — sixty-six places typical in major cities, twenty-seven in small country towns. But tested directly against non-compliance in capacity bands, the smallest services sit at nine-point-three percent, the largest at eight-point-six — not even statistically significant. A bigger centre is no safer bet — a new rural service doesn't need city-sized capacity to meet the standard.</a:t>
             </a:r>
             <a:endParaRPr lang="en-US" dirty="0"/>
           </a:p>
@@ -1312,7 +1313,7 @@
           <a:p>
             <a:r>
               <a:rPr lang="en-US" dirty="0"/>
-              <a:t>Opening hours shows the clearest relationship of the three — seven percent non-compliant under forty-five hours a week, rising to nineteen percent for the longest-opening services, more than double. And closing the loop on Problem 1: transport still doesn't move capacity or hours in any meaningful way — its small compliance effect from Chart 5 stands on its own. Two of three operational levers actually predict whether a service meets the standard; one is noise dressed up as insight.</a:t>
+              <a:t>A data trap first: approvals-per-year spikes in 2012 — over four thousand in one year. Read naively, that's explosive growth. It isn't — the National Quality Framework commenced that January and bulk-transferred every already-operating service onto new numbers, not newly opened ones. The right-hand panel is the real story: grouped by when they were actually approved, services from 2019 onward sit at eleven percent non-compliant, against eight-point-four percent for pre-2012, long-established services. Newer services simply haven't had the years to embed practice yet. That's the strongest operational signal in this whole analysis.</a:t>
             </a:r>
             <a:endParaRPr lang="en-US" dirty="0"/>
           </a:p>
@@ -1400,7 +1401,7 @@
           <a:p>
             <a:r>
               <a:rPr lang="en-US" dirty="0"/>
-              <a:t>Back to the budget question. One: the Northern Territory is the clearest case for urgent, statewide compliance intervention in educational program and governance — a legal-minimum problem, not a generic audit. Tasmania, South Australia and WA aren't far behind. Two: new-service funding has a named destination — WA's and the NT's Bounded Localities, forty-one and thirty kilometres from a family's nearest backup option. Three: transport connectivity is a rural investment priority, real but small as a quality lever — fund it for equity, don't oversell it. And four: give newly-approved services a support pathway, not a compliance one — they just haven't had the years yet. A budget with a reason behind every line. Thank you.</a:t>
+              <a:t>Opening hours shows the clearest relationship of the three — seven percent non-compliant under forty-five hours a week, rising to nineteen percent for the longest-opening services, more than double. And closing the loop on Problem 1: transport still doesn't move capacity or hours in any meaningful way — its small compliance effect from Chart 5 stands on its own. Two of three operational levers actually predict whether a service meets the standard; one is noise dressed up as insight.</a:t>
             </a:r>
             <a:endParaRPr lang="en-US" dirty="0"/>
           </a:p>
@@ -1530,6 +1531,94 @@
 </p:notes>
 </file>
 
+<file path=ppt/notesSlides/notesSlide20.xml><?xml version="1.0" encoding="utf-8"?>
+<p:notes xmlns:a="http://schemas.openxmlformats.org/drawingml/2006/main" xmlns:r="http://schemas.openxmlformats.org/officeDocument/2006/relationships" xmlns:p="http://schemas.openxmlformats.org/presentationml/2006/main">
+  <p:cSld>
+    <p:spTree>
+      <p:nvGrpSpPr>
+        <p:cNvPr id="1" name=""/>
+        <p:cNvGrpSpPr/>
+        <p:nvPr/>
+      </p:nvGrpSpPr>
+      <p:grpSpPr>
+        <a:xfrm>
+          <a:off x="0" y="0"/>
+          <a:ext cx="0" cy="0"/>
+          <a:chOff x="0" y="0"/>
+          <a:chExt cx="0" cy="0"/>
+        </a:xfrm>
+      </p:grpSpPr>
+      <p:sp>
+        <p:nvSpPr>
+          <p:cNvPr id="2" name="Slide Image Placeholder 1"/>
+          <p:cNvSpPr>
+            <a:spLocks noGrp="1" noRot="1" noChangeAspect="1"/>
+          </p:cNvSpPr>
+          <p:nvPr>
+            <p:ph type="sldImg"/>
+          </p:nvPr>
+        </p:nvSpPr>
+        <p:spPr/>
+      </p:sp>
+      <p:sp>
+        <p:nvSpPr>
+          <p:cNvPr id="3" name="Notes Placeholder 2"/>
+          <p:cNvSpPr>
+            <a:spLocks noGrp="1"/>
+          </p:cNvSpPr>
+          <p:nvPr>
+            <p:ph type="body" idx="1"/>
+          </p:nvPr>
+        </p:nvSpPr>
+        <p:spPr/>
+        <p:txBody>
+          <a:bodyPr/>
+          <a:lstStyle/>
+          <a:p>
+            <a:r>
+              <a:rPr lang="en-US" dirty="0"/>
+              <a:t>Back to the budget question. One: the Northern Territory is the clearest case for urgent, statewide compliance intervention in educational program and governance — a legal-minimum problem, not a generic audit. Tasmania, South Australia and WA aren't far behind. Two: new-service funding has a named destination — WA's and the NT's Bounded Localities, forty-one and thirty kilometres from a family's nearest backup option. Three: transport connectivity is a rural investment priority, real but small as a quality lever — fund it for equity, don't oversell it. And four: give newly-approved services a support pathway, not a compliance one — they just haven't had the years yet. A budget with a reason behind every line. Thank you.</a:t>
+            </a:r>
+            <a:endParaRPr lang="en-US" dirty="0"/>
+          </a:p>
+        </p:txBody>
+      </p:sp>
+      <p:sp>
+        <p:nvSpPr>
+          <p:cNvPr id="4" name="Slide Number Placeholder 3"/>
+          <p:cNvSpPr>
+            <a:spLocks noGrp="1"/>
+          </p:cNvSpPr>
+          <p:nvPr>
+            <p:ph type="sldNum" sz="quarter" idx="10"/>
+          </p:nvPr>
+        </p:nvSpPr>
+        <p:spPr/>
+        <p:txBody>
+          <a:bodyPr/>
+          <a:lstStyle/>
+          <a:p>
+            <a:fld id="{F7021451-1387-4CA6-816F-3879F97B5CBC}" type="slidenum">
+              <a:rPr lang="en-US"/>
+              <a:t>20</a:t>
+            </a:fld>
+            <a:endParaRPr lang="en-US"/>
+          </a:p>
+        </p:txBody>
+      </p:sp>
+    </p:spTree>
+    <p:extLst>
+      <p:ext uri="{BB962C8B-B14F-4D97-AF65-F5344CB8AC3E}">
+        <p14:creationId xmlns:p14="http://schemas.microsoft.com/office/powerpoint/2010/main" val="1024086991"/>
+      </p:ext>
+    </p:extLst>
+  </p:cSld>
+  <p:clrMapOvr>
+    <a:masterClrMapping/>
+  </p:clrMapOvr>
+</p:notes>
+</file>
+
 <file path=ppt/notesSlides/notesSlide3.xml><?xml version="1.0" encoding="utf-8"?>
 <p:notes xmlns:a="http://schemas.openxmlformats.org/drawingml/2006/main" xmlns:r="http://schemas.openxmlformats.org/officeDocument/2006/relationships" xmlns:p="http://schemas.openxmlformats.org/presentationml/2006/main">
   <p:cSld>
@@ -1576,7 +1665,7 @@
           <a:p>
             <a:r>
               <a:rPr lang="en-US" dirty="0"/>
-              <a:t>First problem: all eight states and territories apply the same National Law. If quality outcomes are wildly inconsistent anyway, that's either a resourcing gap or an enforcement gap — and knowing which one matters, because they need completely different fixes.</a:t>
+              <a:t>Before the findings, a quick word on what this analysis can and can't claim. It's a single snapshot, not a longitudinal study — comparisons across approval cohorts are different services, not the same services followed over time. Quality ratings are each state's own administrative assessment, so I can't independently verify assessor consistency across jurisdictions. Every relationship I've tested — transport, hours, capacity, approval date — is correlational, not causal. One comparison, the state-level rurality-versus-connectivity chart, has only eight data points, so I've flagged that one as illustrative rather than conclusive. And definitions like "well-connected" and "non-compliance" are reasonable, stated choices — change the threshold and the specific numbers move, even if the overall pattern doesn't.</a:t>
             </a:r>
             <a:endParaRPr lang="en-US" dirty="0"/>
           </a:p>
@@ -1664,7 +1753,7 @@
           <a:p>
             <a:r>
               <a:rPr lang="en-US" dirty="0"/>
-              <a:t>They are wildly inconsistent — and I'm ranking this by who's actually failing the legal minimum, not who's excelling. The Northern Territory is worst: twenty-two percent of its services rated Working Towards NQS or Significant Improvement Required. Victoria is best, at four percent. Same law, five-times difference. That's not noise — that's a finding that should already be uncomfortable for a national regulator.</a:t>
+              <a:t>First problem: all eight states and territories apply the same National Law. If quality outcomes are wildly inconsistent anyway, that's either a resourcing gap or an enforcement gap — and knowing which one matters, because they need completely different fixes.</a:t>
             </a:r>
             <a:endParaRPr lang="en-US" dirty="0"/>
           </a:p>
@@ -1752,7 +1841,7 @@
           <a:p>
             <a:r>
               <a:rPr lang="en-US" dirty="0"/>
-              <a:t>It's not just geography, either. Ranked the same way as Chart 1 — worst compliance first — Family Day Care is the clear outlier: twenty-two percent non-compliant, roughly double Long Day Care and Outside School Hours Care, and miles behind standalone preschools at under two percent. Family Day Care is a small slice of the sector by numbers, but it's the single worst-performing service type in the country.</a:t>
+              <a:t>They are wildly inconsistent — and I'm ranking this by who's actually failing the legal minimum, not who's excelling. The Northern Territory is worst: twenty-two percent of its services rated Working Towards NQS or Significant Improvement Required. Victoria is best, at four percent. Same law, five-times difference. That's not noise — that's a finding that should already be uncomfortable for a national regulator.</a:t>
             </a:r>
             <a:endParaRPr lang="en-US" dirty="0"/>
           </a:p>
@@ -1840,7 +1929,7 @@
           <a:p>
             <a:r>
               <a:rPr lang="en-US" dirty="0"/>
-              <a:t>This chart zooms from the overall number into which specific component drives it. The Northern Territory and Tasmania still lead — but by this component-level measure, Western Australia and South Australia join them near the top, up to fourteen percent non-compliant in a single quality area, even though WA ranked only fourth on the overall measure in Chart 1. A state's overall rating isn't a simple average of its seven components, so a state can look mid-table overall while hiding a real problem in one specific area — concentrated here in Quality Area 1, educational program, and Quality Area 7, governance.</a:t>
+              <a:t>It's not just geography, either. Ranked the same way as Chart 1 — worst compliance first — Family Day Care is the clear outlier: twenty-two percent non-compliant, roughly double Long Day Care and Outside School Hours Care, and miles behind standalone preschools at under two percent. Family Day Care is a small slice of the sector by numbers, but it's the single worst-performing service type in the country.</a:t>
             </a:r>
             <a:endParaRPr lang="en-US" dirty="0"/>
           </a:p>
@@ -1928,7 +2017,7 @@
           <a:p>
             <a:r>
               <a:rPr lang="en-US" dirty="0"/>
-              <a:t>And it's local enough to act on directly — you can see clusters of underperforming services around Perth and Adelaide specifically, which means a support team could be deployed to a cluster, not spread across an entire state.</a:t>
+              <a:t>This chart zooms from the overall number into which specific component drives it. The Northern Territory and Tasmania still lead — but by this component-level measure, Western Australia and South Australia join them near the top, up to fourteen percent non-compliant in a single quality area, even though WA ranked only fourth on the overall measure in Chart 1. A state's overall rating isn't a simple average of its seven components, so a state can look mid-table overall while hiding a real problem in one specific area — concentrated here in Quality Area 1, educational program, and Quality Area 7, governance.</a:t>
             </a:r>
             <a:endParaRPr lang="en-US" dirty="0"/>
           </a:p>
@@ -2016,7 +2105,7 @@
           <a:p>
             <a:r>
               <a:rPr lang="en-US" dirty="0"/>
-              <a:t>Before recommending a fix, I need to test the obvious hypothesis: does poor transport access damage quality? I looked at the share of services rated below the NQS standard by distance to the nearest train station. It rises from seven-point-six percent for the closest services to ten-point-three for the furthest — real and significant, but small. A transport upgrade might nudge quality slightly; it won't close a ten-times state-level gap. A minor risk factor beside much bigger drivers.</a:t>
+              <a:t>And it's local enough to act on directly — you can see clusters of underperforming services around Perth and Adelaide specifically, which means a support team could be deployed to a cluster, not spread across an entire state.</a:t>
             </a:r>
             <a:endParaRPr lang="en-US" dirty="0"/>
           </a:p>
@@ -2104,7 +2193,7 @@
           <a:p>
             <a:r>
               <a:rPr lang="en-US" dirty="0"/>
-              <a:t>Second problem, and the assignment sets four specific questions here. I'm answering each one directly, with a chart built to prove a claim, not just describe a distribution.</a:t>
+              <a:t>Before recommending a fix, I need to test the obvious hypothesis: does poor transport access damage quality? I looked at the share of services rated below the NQS standard by distance to the nearest train station. It rises from seven-point-six percent for the closest services to ten-point-three for the furthest — real and significant, but small. A transport upgrade might nudge quality slightly; it won't close a ten-times state-level gap. A minor risk factor beside much bigger drivers.</a:t>
             </a:r>
             <a:endParaRPr lang="en-US" dirty="0"/>
           </a:p>
@@ -2706,7 +2795,7 @@
     <p:bg>
       <p:bgPr>
         <a:solidFill>
-          <a:srgbClr val="FFFFFF"/>
+          <a:srgbClr val="1E2761"/>
         </a:solidFill>
       </p:bgPr>
     </p:bg>
@@ -2726,13 +2815,72 @@
       </p:grpSpPr>
       <p:sp>
         <p:nvSpPr>
-          <p:cNvPr id="2" name="Text 0"/>
-          <p:cNvSpPr txBox="1"/>
-          <p:nvPr/>
-        </p:nvSpPr>
-        <p:spPr>
-          <a:xfrm>
-            <a:off x="640080" y="457200"/>
+          <p:cNvPr id="2" name="Shape 0"/>
+          <p:cNvSpPr/>
+          <p:nvPr/>
+        </p:nvSpPr>
+        <p:spPr>
+          <a:xfrm>
+            <a:off x="822960" y="777240"/>
+            <a:ext cx="1051560" cy="1051560"/>
+          </a:xfrm>
+          <a:prstGeom prst="ellipse">
+            <a:avLst/>
+          </a:prstGeom>
+          <a:solidFill>
+            <a:srgbClr val="E34948"/>
+          </a:solidFill>
+          <a:ln/>
+        </p:spPr>
+      </p:sp>
+      <p:sp>
+        <p:nvSpPr>
+          <p:cNvPr id="3" name="Text 1"/>
+          <p:cNvSpPr txBox="1"/>
+          <p:nvPr/>
+        </p:nvSpPr>
+        <p:spPr>
+          <a:xfrm>
+            <a:off x="822960" y="777240"/>
+            <a:ext cx="1051560" cy="1051560"/>
+          </a:xfrm>
+          <a:prstGeom prst="rect">
+            <a:avLst/>
+          </a:prstGeom>
+          <a:noFill/>
+          <a:ln/>
+        </p:spPr>
+        <p:txBody>
+          <a:bodyPr wrap="square" lIns="0" tIns="0" rIns="0" bIns="0" rtlCol="0" anchor="ctr"/>
+          <a:lstStyle/>
+          <a:p>
+            <a:pPr algn="ctr" indent="0" marL="0">
+              <a:buNone/>
+            </a:pPr>
+            <a:r>
+              <a:rPr lang="en-US" sz="3400" b="1" dirty="0">
+                <a:solidFill>
+                  <a:srgbClr val="FFFFFF"/>
+                </a:solidFill>
+                <a:latin typeface="Cambria" pitchFamily="34" charset="0"/>
+                <a:ea typeface="Cambria" pitchFamily="34" charset="-122"/>
+                <a:cs typeface="Cambria" pitchFamily="34" charset="-120"/>
+              </a:rPr>
+              <a:t>2</a:t>
+            </a:r>
+            <a:endParaRPr lang="en-US" sz="3400" dirty="0"/>
+          </a:p>
+        </p:txBody>
+      </p:sp>
+      <p:sp>
+        <p:nvSpPr>
+          <p:cNvPr id="4" name="Text 2"/>
+          <p:cNvSpPr txBox="1"/>
+          <p:nvPr/>
+        </p:nvSpPr>
+        <p:spPr>
+          <a:xfrm>
+            <a:off x="2148840" y="1024128"/>
             <a:ext cx="7315200" cy="320040"/>
           </a:xfrm>
           <a:prstGeom prst="rect">
@@ -2751,13 +2899,13 @@
             <a:r>
               <a:rPr lang="en-US" sz="1300" b="1" spc="200" kern="0" dirty="0">
                 <a:solidFill>
-                  <a:srgbClr val="E34948"/>
+                  <a:srgbClr val="CADCFC"/>
                 </a:solidFill>
                 <a:latin typeface="Calibri" pitchFamily="34" charset="0"/>
                 <a:ea typeface="Calibri" pitchFamily="34" charset="-122"/>
                 <a:cs typeface="Calibri" pitchFamily="34" charset="-120"/>
               </a:rPr>
-              <a:t>PROBLEM 2 · CHART 6</a:t>
+              <a:t>PROBLEM 2</a:t>
             </a:r>
             <a:endParaRPr lang="en-US" sz="1300" dirty="0"/>
           </a:p>
@@ -2765,14 +2913,14 @@
       </p:sp>
       <p:sp>
         <p:nvSpPr>
-          <p:cNvPr id="3" name="Text 1"/>
-          <p:cNvSpPr txBox="1"/>
-          <p:nvPr/>
-        </p:nvSpPr>
-        <p:spPr>
-          <a:xfrm>
-            <a:off x="640080" y="731520"/>
-            <a:ext cx="10911535" cy="960120"/>
+          <p:cNvPr id="5" name="Text 3"/>
+          <p:cNvSpPr txBox="1"/>
+          <p:nvPr/>
+        </p:nvSpPr>
+        <p:spPr>
+          <a:xfrm>
+            <a:off x="822960" y="2331720"/>
+            <a:ext cx="9875520" cy="2011680"/>
           </a:xfrm>
           <a:prstGeom prst="rect">
             <a:avLst/>
@@ -2786,59 +2934,70 @@
           <a:p>
             <a:pPr indent="0" marL="0">
               <a:lnSpc>
-                <a:spcPts val="2800"/>
+                <a:spcPts val="4000"/>
               </a:lnSpc>
               <a:buNone/>
             </a:pPr>
             <a:r>
-              <a:rPr lang="en-US" sz="2400" b="1" dirty="0">
-                <a:solidFill>
-                  <a:srgbClr val="1E2761"/>
+              <a:rPr lang="en-US" sz="3400" b="1" dirty="0">
+                <a:solidFill>
+                  <a:srgbClr val="FFFFFF"/>
                 </a:solidFill>
                 <a:latin typeface="Cambria" pitchFamily="34" charset="0"/>
                 <a:ea typeface="Cambria" pitchFamily="34" charset="-122"/>
                 <a:cs typeface="Cambria" pitchFamily="34" charset="-120"/>
               </a:rPr>
-              <a:t>Services are 12,000x denser in cities than the country</a:t>
-            </a:r>
-            <a:endParaRPr lang="en-US" sz="2400" dirty="0"/>
-          </a:p>
-        </p:txBody>
-      </p:sp>
-      <p:pic>
-        <p:nvPicPr>
-          <p:cNvPr id="4" name="Image 0" descr="/home/user/Mart/outputs/figures/06_geographic_distribution.png">    </p:cNvPr>
-          <p:cNvPicPr>
-            <a:picLocks noChangeAspect="1"/>
-          </p:cNvPicPr>
-          <p:nvPr/>
-        </p:nvPicPr>
-        <p:blipFill>
-          <a:blip r:embed="rId1"/>
-          <a:stretch>
-            <a:fillRect/>
-          </a:stretch>
-        </p:blipFill>
-        <p:spPr>
-          <a:xfrm>
-            <a:off x="2725968" y="1783080"/>
-            <a:ext cx="6739759" cy="4343400"/>
-          </a:xfrm>
-          <a:prstGeom prst="rect">
-            <a:avLst/>
-          </a:prstGeom>
-          <a:effectLst>
-            <a:outerShdw sx="100000" sy="100000" kx="0" ky="0" algn="bl" rotWithShape="0" blurRad="101600" dist="38100" dir="5400000">
-              <a:srgbClr val="0F1533">
-                <a:alpha val="35000"/>
-              </a:srgbClr>
-            </a:outerShdw>
-          </a:effectLst>
-        </p:spPr>
-      </p:pic>
-      <p:sp>
-        <p:nvSpPr>
-          <p:cNvPr id="5" name="Text 2"/>
+              <a:t>Are families structurally cut off from services — and where worst?</a:t>
+            </a:r>
+            <a:endParaRPr lang="en-US" sz="3400" dirty="0"/>
+          </a:p>
+        </p:txBody>
+      </p:sp>
+      <p:sp>
+        <p:nvSpPr>
+          <p:cNvPr id="6" name="Text 4"/>
+          <p:cNvSpPr txBox="1"/>
+          <p:nvPr/>
+        </p:nvSpPr>
+        <p:spPr>
+          <a:xfrm>
+            <a:off x="822960" y="4434840"/>
+            <a:ext cx="9326880" cy="822960"/>
+          </a:xfrm>
+          <a:prstGeom prst="rect">
+            <a:avLst/>
+          </a:prstGeom>
+          <a:noFill/>
+          <a:ln/>
+        </p:spPr>
+        <p:txBody>
+          <a:bodyPr wrap="square" lIns="0" tIns="0" rIns="0" bIns="0" rtlCol="0" anchor="ctr"/>
+          <a:lstStyle/>
+          <a:p>
+            <a:pPr indent="0" marL="0">
+              <a:lnSpc>
+                <a:spcPts val="2200"/>
+              </a:lnSpc>
+              <a:buNone/>
+            </a:pPr>
+            <a:r>
+              <a:rPr lang="en-US" sz="1600" i="1" dirty="0">
+                <a:solidFill>
+                  <a:srgbClr val="CADCFC"/>
+                </a:solidFill>
+                <a:latin typeface="Calibri" pitchFamily="34" charset="0"/>
+                <a:ea typeface="Calibri" pitchFamily="34" charset="-122"/>
+                <a:cs typeface="Calibri" pitchFamily="34" charset="-120"/>
+              </a:rPr>
+              <a:t>Four assignment requirements, four charts built to prove a claim — plus one gut-check chart.</a:t>
+            </a:r>
+            <a:endParaRPr lang="en-US" sz="1600" dirty="0"/>
+          </a:p>
+        </p:txBody>
+      </p:sp>
+      <p:sp>
+        <p:nvSpPr>
+          <p:cNvPr id="7" name="Text 5"/>
           <p:cNvSpPr txBox="1"/>
           <p:nvPr/>
         </p:nvSpPr>
@@ -2940,7 +3099,7 @@
                 <a:ea typeface="Calibri" pitchFamily="34" charset="-122"/>
                 <a:cs typeface="Calibri" pitchFamily="34" charset="-120"/>
               </a:rPr>
-              <a:t>PROBLEM 2 · CHART 7</a:t>
+              <a:t>PROBLEM 2 · CHART 6</a:t>
             </a:r>
             <a:endParaRPr lang="en-US" sz="1300" dirty="0"/>
           </a:p>
@@ -2982,7 +3141,7 @@
                 <a:ea typeface="Cambria" pitchFamily="34" charset="-122"/>
                 <a:cs typeface="Cambria" pitchFamily="34" charset="-120"/>
               </a:rPr>
-              <a:t>WA's Bounded Localities: the biggest coverage gap nationally</a:t>
+              <a:t>Services are 12,000x denser in cities than the country</a:t>
             </a:r>
             <a:endParaRPr lang="en-US" sz="2400" dirty="0"/>
           </a:p>
@@ -2990,7 +3149,7 @@
       </p:sp>
       <p:pic>
         <p:nvPicPr>
-          <p:cNvPr id="4" name="Image 0" descr="/home/user/Mart/outputs/figures/07_underserved_regions.png">    </p:cNvPr>
+          <p:cNvPr id="4" name="Image 0" descr="/tmp/claude-0/-home-user-Mart/76d1eb32-37a9-556d-8be9-05e0ce1a5b50/scratchpad/deck/clean_charts/06_geographic_distribution.png">    </p:cNvPr>
           <p:cNvPicPr>
             <a:picLocks noChangeAspect="1"/>
           </p:cNvPicPr>
@@ -3004,8 +3163,8 @@
         </p:blipFill>
         <p:spPr>
           <a:xfrm>
-            <a:off x="2344729" y="1783080"/>
-            <a:ext cx="7502236" cy="4343400"/>
+            <a:off x="2668271" y="1783080"/>
+            <a:ext cx="6855153" cy="4343400"/>
           </a:xfrm>
           <a:prstGeom prst="rect">
             <a:avLst/>
@@ -3123,7 +3282,7 @@
                 <a:ea typeface="Calibri" pitchFamily="34" charset="-122"/>
                 <a:cs typeface="Calibri" pitchFamily="34" charset="-120"/>
               </a:rPr>
-              <a:t>PROBLEM 2 · CHART 8 (BRIDGE)</a:t>
+              <a:t>PROBLEM 2 · CHART 7</a:t>
             </a:r>
             <a:endParaRPr lang="en-US" sz="1300" dirty="0"/>
           </a:p>
@@ -3165,7 +3324,7 @@
                 <a:ea typeface="Cambria" pitchFamily="34" charset="-122"/>
                 <a:cs typeface="Cambria" pitchFamily="34" charset="-120"/>
               </a:rPr>
-              <a:t>WA's gap is a pocket problem — not a statewide one</a:t>
+              <a:t>WA's Bounded Localities: the biggest coverage gap nationally</a:t>
             </a:r>
             <a:endParaRPr lang="en-US" sz="2400" dirty="0"/>
           </a:p>
@@ -3173,7 +3332,7 @@
       </p:sp>
       <p:pic>
         <p:nvPicPr>
-          <p:cNvPr id="4" name="Image 0" descr="/home/user/Mart/outputs/figures/08_state_connectivity_vs_rurality.png">    </p:cNvPr>
+          <p:cNvPr id="4" name="Image 0" descr="/tmp/claude-0/-home-user-Mart/76d1eb32-37a9-556d-8be9-05e0ce1a5b50/scratchpad/deck/clean_charts/07_underserved_regions.png">    </p:cNvPr>
           <p:cNvPicPr>
             <a:picLocks noChangeAspect="1"/>
           </p:cNvPicPr>
@@ -3187,8 +3346,8 @@
         </p:blipFill>
         <p:spPr>
           <a:xfrm>
-            <a:off x="3088878" y="1783080"/>
-            <a:ext cx="6013938" cy="4343400"/>
+            <a:off x="2294362" y="1783080"/>
+            <a:ext cx="7602972" cy="4343400"/>
           </a:xfrm>
           <a:prstGeom prst="rect">
             <a:avLst/>
@@ -3306,7 +3465,7 @@
                 <a:ea typeface="Calibri" pitchFamily="34" charset="-122"/>
                 <a:cs typeface="Calibri" pitchFamily="34" charset="-120"/>
               </a:rPr>
-              <a:t>PROBLEM 2 · CHART 9</a:t>
+              <a:t>PROBLEM 2 · CHART 8 (BRIDGE)</a:t>
             </a:r>
             <a:endParaRPr lang="en-US" sz="1300" dirty="0"/>
           </a:p>
@@ -3348,7 +3507,7 @@
                 <a:ea typeface="Cambria" pitchFamily="34" charset="-122"/>
                 <a:cs typeface="Cambria" pitchFamily="34" charset="-120"/>
               </a:rPr>
-              <a:t>83% well-connected nationally, just 21% in country towns</a:t>
+              <a:t>WA's gap is a pocket problem — not a statewide one</a:t>
             </a:r>
             <a:endParaRPr lang="en-US" sz="2400" dirty="0"/>
           </a:p>
@@ -3356,7 +3515,7 @@
       </p:sp>
       <p:pic>
         <p:nvPicPr>
-          <p:cNvPr id="4" name="Image 0" descr="/home/user/Mart/outputs/figures/09_transport_connectivity.png">    </p:cNvPr>
+          <p:cNvPr id="4" name="Image 0" descr="/tmp/claude-0/-home-user-Mart/76d1eb32-37a9-556d-8be9-05e0ce1a5b50/scratchpad/deck/clean_charts/08_state_connectivity_vs_rurality.png">    </p:cNvPr>
           <p:cNvPicPr>
             <a:picLocks noChangeAspect="1"/>
           </p:cNvPicPr>
@@ -3370,8 +3529,8 @@
         </p:blipFill>
         <p:spPr>
           <a:xfrm>
-            <a:off x="2725968" y="1783080"/>
-            <a:ext cx="6739759" cy="4343400"/>
+            <a:off x="3071832" y="1783080"/>
+            <a:ext cx="6048031" cy="4343400"/>
           </a:xfrm>
           <a:prstGeom prst="rect">
             <a:avLst/>
@@ -3489,7 +3648,7 @@
                 <a:ea typeface="Calibri" pitchFamily="34" charset="-122"/>
                 <a:cs typeface="Calibri" pitchFamily="34" charset="-120"/>
               </a:rPr>
-              <a:t>PROBLEM 2 · CHART 10</a:t>
+              <a:t>PROBLEM 2 · CHART 9</a:t>
             </a:r>
             <a:endParaRPr lang="en-US" sz="1300" dirty="0"/>
           </a:p>
@@ -3531,7 +3690,7 @@
                 <a:ea typeface="Cambria" pitchFamily="34" charset="-122"/>
                 <a:cs typeface="Cambria" pitchFamily="34" charset="-120"/>
               </a:rPr>
-              <a:t>The transport gap is concentrated, not scattered</a:t>
+              <a:t>83% well-connected nationally, just 21% in country towns</a:t>
             </a:r>
             <a:endParaRPr lang="en-US" sz="2400" dirty="0"/>
           </a:p>
@@ -3539,7 +3698,7 @@
       </p:sp>
       <p:pic>
         <p:nvPicPr>
-          <p:cNvPr id="4" name="Image 0" descr="/home/user/Mart/outputs/figures/10_spatial_connectivity.png">    </p:cNvPr>
+          <p:cNvPr id="4" name="Image 0" descr="/tmp/claude-0/-home-user-Mart/76d1eb32-37a9-556d-8be9-05e0ce1a5b50/scratchpad/deck/clean_charts/09_transport_connectivity.png">    </p:cNvPr>
           <p:cNvPicPr>
             <a:picLocks noChangeAspect="1"/>
           </p:cNvPicPr>
@@ -3553,8 +3712,8 @@
         </p:blipFill>
         <p:spPr>
           <a:xfrm>
-            <a:off x="3652685" y="1783080"/>
-            <a:ext cx="4886325" cy="4343400"/>
+            <a:off x="2698497" y="1783080"/>
+            <a:ext cx="6794702" cy="4343400"/>
           </a:xfrm>
           <a:prstGeom prst="rect">
             <a:avLst/>
@@ -3618,6 +3777,189 @@
 <file path=ppt/slides/slide15.xml><?xml version="1.0" encoding="utf-8"?>
 <p:sld xmlns:a="http://schemas.openxmlformats.org/drawingml/2006/main" xmlns:r="http://schemas.openxmlformats.org/officeDocument/2006/relationships" xmlns:p="http://schemas.openxmlformats.org/presentationml/2006/main">
   <p:cSld name="Slide 15">
+    <p:bg>
+      <p:bgPr>
+        <a:solidFill>
+          <a:srgbClr val="FFFFFF"/>
+        </a:solidFill>
+      </p:bgPr>
+    </p:bg>
+    <p:spTree>
+      <p:nvGrpSpPr>
+        <p:cNvPr id="1" name=""/>
+        <p:cNvGrpSpPr/>
+        <p:nvPr/>
+      </p:nvGrpSpPr>
+      <p:grpSpPr>
+        <a:xfrm>
+          <a:off x="0" y="0"/>
+          <a:ext cx="0" cy="0"/>
+          <a:chOff x="0" y="0"/>
+          <a:chExt cx="0" cy="0"/>
+        </a:xfrm>
+      </p:grpSpPr>
+      <p:sp>
+        <p:nvSpPr>
+          <p:cNvPr id="2" name="Text 0"/>
+          <p:cNvSpPr txBox="1"/>
+          <p:nvPr/>
+        </p:nvSpPr>
+        <p:spPr>
+          <a:xfrm>
+            <a:off x="640080" y="457200"/>
+            <a:ext cx="7315200" cy="320040"/>
+          </a:xfrm>
+          <a:prstGeom prst="rect">
+            <a:avLst/>
+          </a:prstGeom>
+          <a:noFill/>
+          <a:ln/>
+        </p:spPr>
+        <p:txBody>
+          <a:bodyPr wrap="square" lIns="0" tIns="0" rIns="0" bIns="0" rtlCol="0" anchor="ctr"/>
+          <a:lstStyle/>
+          <a:p>
+            <a:pPr indent="0" marL="0">
+              <a:buNone/>
+            </a:pPr>
+            <a:r>
+              <a:rPr lang="en-US" sz="1300" b="1" spc="200" kern="0" dirty="0">
+                <a:solidFill>
+                  <a:srgbClr val="E34948"/>
+                </a:solidFill>
+                <a:latin typeface="Calibri" pitchFamily="34" charset="0"/>
+                <a:ea typeface="Calibri" pitchFamily="34" charset="-122"/>
+                <a:cs typeface="Calibri" pitchFamily="34" charset="-120"/>
+              </a:rPr>
+              <a:t>PROBLEM 2 · CHART 10</a:t>
+            </a:r>
+            <a:endParaRPr lang="en-US" sz="1300" dirty="0"/>
+          </a:p>
+        </p:txBody>
+      </p:sp>
+      <p:sp>
+        <p:nvSpPr>
+          <p:cNvPr id="3" name="Text 1"/>
+          <p:cNvSpPr txBox="1"/>
+          <p:nvPr/>
+        </p:nvSpPr>
+        <p:spPr>
+          <a:xfrm>
+            <a:off x="640080" y="731520"/>
+            <a:ext cx="10911535" cy="960120"/>
+          </a:xfrm>
+          <a:prstGeom prst="rect">
+            <a:avLst/>
+          </a:prstGeom>
+          <a:noFill/>
+          <a:ln/>
+        </p:spPr>
+        <p:txBody>
+          <a:bodyPr wrap="square" lIns="0" tIns="0" rIns="0" bIns="0" rtlCol="0" anchor="t"/>
+          <a:lstStyle/>
+          <a:p>
+            <a:pPr indent="0" marL="0">
+              <a:lnSpc>
+                <a:spcPts val="2800"/>
+              </a:lnSpc>
+              <a:buNone/>
+            </a:pPr>
+            <a:r>
+              <a:rPr lang="en-US" sz="2400" b="1" dirty="0">
+                <a:solidFill>
+                  <a:srgbClr val="1E2761"/>
+                </a:solidFill>
+                <a:latin typeface="Cambria" pitchFamily="34" charset="0"/>
+                <a:ea typeface="Cambria" pitchFamily="34" charset="-122"/>
+                <a:cs typeface="Cambria" pitchFamily="34" charset="-120"/>
+              </a:rPr>
+              <a:t>The transport gap is concentrated, not scattered</a:t>
+            </a:r>
+            <a:endParaRPr lang="en-US" sz="2400" dirty="0"/>
+          </a:p>
+        </p:txBody>
+      </p:sp>
+      <p:pic>
+        <p:nvPicPr>
+          <p:cNvPr id="4" name="Image 0" descr="/tmp/claude-0/-home-user-Mart/76d1eb32-37a9-556d-8be9-05e0ce1a5b50/scratchpad/deck/clean_charts/10_spatial_connectivity.png">    </p:cNvPr>
+          <p:cNvPicPr>
+            <a:picLocks noChangeAspect="1"/>
+          </p:cNvPicPr>
+          <p:nvPr/>
+        </p:nvPicPr>
+        <p:blipFill>
+          <a:blip r:embed="rId1"/>
+          <a:stretch>
+            <a:fillRect/>
+          </a:stretch>
+        </p:blipFill>
+        <p:spPr>
+          <a:xfrm>
+            <a:off x="4183537" y="1783080"/>
+            <a:ext cx="3824620" cy="4343400"/>
+          </a:xfrm>
+          <a:prstGeom prst="rect">
+            <a:avLst/>
+          </a:prstGeom>
+          <a:effectLst>
+            <a:outerShdw sx="100000" sy="100000" kx="0" ky="0" algn="bl" rotWithShape="0" blurRad="101600" dist="38100" dir="5400000">
+              <a:srgbClr val="0F1533">
+                <a:alpha val="35000"/>
+              </a:srgbClr>
+            </a:outerShdw>
+          </a:effectLst>
+        </p:spPr>
+      </p:pic>
+      <p:sp>
+        <p:nvSpPr>
+          <p:cNvPr id="5" name="Text 2"/>
+          <p:cNvSpPr txBox="1"/>
+          <p:nvPr/>
+        </p:nvSpPr>
+        <p:spPr>
+          <a:xfrm>
+            <a:off x="11368735" y="6355080"/>
+            <a:ext cx="548640" cy="320040"/>
+          </a:xfrm>
+          <a:prstGeom prst="rect">
+            <a:avLst/>
+          </a:prstGeom>
+          <a:noFill/>
+          <a:ln/>
+        </p:spPr>
+        <p:txBody>
+          <a:bodyPr wrap="square" lIns="0" tIns="0" rIns="0" bIns="0" rtlCol="0" anchor="ctr"/>
+          <a:lstStyle/>
+          <a:p>
+            <a:pPr algn="r" indent="0" marL="0">
+              <a:buNone/>
+            </a:pPr>
+            <a:r>
+              <a:rPr lang="en-US" sz="1000" dirty="0">
+                <a:solidFill>
+                  <a:srgbClr val="5B6472"/>
+                </a:solidFill>
+                <a:latin typeface="Calibri" pitchFamily="34" charset="0"/>
+                <a:ea typeface="Calibri" pitchFamily="34" charset="-122"/>
+                <a:cs typeface="Calibri" pitchFamily="34" charset="-120"/>
+              </a:rPr>
+              <a:t>15</a:t>
+            </a:r>
+            <a:endParaRPr lang="en-US" sz="1000" dirty="0"/>
+          </a:p>
+        </p:txBody>
+      </p:sp>
+    </p:spTree>
+  </p:cSld>
+  <p:clrMapOvr>
+    <a:masterClrMapping/>
+  </p:clrMapOvr>
+</p:sld>
+</file>
+
+<file path=ppt/slides/slide16.xml><?xml version="1.0" encoding="utf-8"?>
+<p:sld xmlns:a="http://schemas.openxmlformats.org/drawingml/2006/main" xmlns:r="http://schemas.openxmlformats.org/officeDocument/2006/relationships" xmlns:p="http://schemas.openxmlformats.org/presentationml/2006/main">
+  <p:cSld name="Slide 16">
     <p:bg>
       <p:bgPr>
         <a:solidFill>
@@ -3824,189 +4166,6 @@
       <p:sp>
         <p:nvSpPr>
           <p:cNvPr id="7" name="Text 5"/>
-          <p:cNvSpPr txBox="1"/>
-          <p:nvPr/>
-        </p:nvSpPr>
-        <p:spPr>
-          <a:xfrm>
-            <a:off x="11368735" y="6355080"/>
-            <a:ext cx="548640" cy="320040"/>
-          </a:xfrm>
-          <a:prstGeom prst="rect">
-            <a:avLst/>
-          </a:prstGeom>
-          <a:noFill/>
-          <a:ln/>
-        </p:spPr>
-        <p:txBody>
-          <a:bodyPr wrap="square" lIns="0" tIns="0" rIns="0" bIns="0" rtlCol="0" anchor="ctr"/>
-          <a:lstStyle/>
-          <a:p>
-            <a:pPr algn="r" indent="0" marL="0">
-              <a:buNone/>
-            </a:pPr>
-            <a:r>
-              <a:rPr lang="en-US" sz="1000" dirty="0">
-                <a:solidFill>
-                  <a:srgbClr val="5B6472"/>
-                </a:solidFill>
-                <a:latin typeface="Calibri" pitchFamily="34" charset="0"/>
-                <a:ea typeface="Calibri" pitchFamily="34" charset="-122"/>
-                <a:cs typeface="Calibri" pitchFamily="34" charset="-120"/>
-              </a:rPr>
-              <a:t>15</a:t>
-            </a:r>
-            <a:endParaRPr lang="en-US" sz="1000" dirty="0"/>
-          </a:p>
-        </p:txBody>
-      </p:sp>
-    </p:spTree>
-  </p:cSld>
-  <p:clrMapOvr>
-    <a:masterClrMapping/>
-  </p:clrMapOvr>
-</p:sld>
-</file>
-
-<file path=ppt/slides/slide16.xml><?xml version="1.0" encoding="utf-8"?>
-<p:sld xmlns:a="http://schemas.openxmlformats.org/drawingml/2006/main" xmlns:r="http://schemas.openxmlformats.org/officeDocument/2006/relationships" xmlns:p="http://schemas.openxmlformats.org/presentationml/2006/main">
-  <p:cSld name="Slide 16">
-    <p:bg>
-      <p:bgPr>
-        <a:solidFill>
-          <a:srgbClr val="FFFFFF"/>
-        </a:solidFill>
-      </p:bgPr>
-    </p:bg>
-    <p:spTree>
-      <p:nvGrpSpPr>
-        <p:cNvPr id="1" name=""/>
-        <p:cNvGrpSpPr/>
-        <p:nvPr/>
-      </p:nvGrpSpPr>
-      <p:grpSpPr>
-        <a:xfrm>
-          <a:off x="0" y="0"/>
-          <a:ext cx="0" cy="0"/>
-          <a:chOff x="0" y="0"/>
-          <a:chExt cx="0" cy="0"/>
-        </a:xfrm>
-      </p:grpSpPr>
-      <p:sp>
-        <p:nvSpPr>
-          <p:cNvPr id="2" name="Text 0"/>
-          <p:cNvSpPr txBox="1"/>
-          <p:nvPr/>
-        </p:nvSpPr>
-        <p:spPr>
-          <a:xfrm>
-            <a:off x="640080" y="457200"/>
-            <a:ext cx="7315200" cy="320040"/>
-          </a:xfrm>
-          <a:prstGeom prst="rect">
-            <a:avLst/>
-          </a:prstGeom>
-          <a:noFill/>
-          <a:ln/>
-        </p:spPr>
-        <p:txBody>
-          <a:bodyPr wrap="square" lIns="0" tIns="0" rIns="0" bIns="0" rtlCol="0" anchor="ctr"/>
-          <a:lstStyle/>
-          <a:p>
-            <a:pPr indent="0" marL="0">
-              <a:buNone/>
-            </a:pPr>
-            <a:r>
-              <a:rPr lang="en-US" sz="1300" b="1" spc="200" kern="0" dirty="0">
-                <a:solidFill>
-                  <a:srgbClr val="E34948"/>
-                </a:solidFill>
-                <a:latin typeface="Calibri" pitchFamily="34" charset="0"/>
-                <a:ea typeface="Calibri" pitchFamily="34" charset="-122"/>
-                <a:cs typeface="Calibri" pitchFamily="34" charset="-120"/>
-              </a:rPr>
-              <a:t>PROBLEM 3 · CHART 11</a:t>
-            </a:r>
-            <a:endParaRPr lang="en-US" sz="1300" dirty="0"/>
-          </a:p>
-        </p:txBody>
-      </p:sp>
-      <p:sp>
-        <p:nvSpPr>
-          <p:cNvPr id="3" name="Text 1"/>
-          <p:cNvSpPr txBox="1"/>
-          <p:nvPr/>
-        </p:nvSpPr>
-        <p:spPr>
-          <a:xfrm>
-            <a:off x="640080" y="731520"/>
-            <a:ext cx="10911535" cy="960120"/>
-          </a:xfrm>
-          <a:prstGeom prst="rect">
-            <a:avLst/>
-          </a:prstGeom>
-          <a:noFill/>
-          <a:ln/>
-        </p:spPr>
-        <p:txBody>
-          <a:bodyPr wrap="square" lIns="0" tIns="0" rIns="0" bIns="0" rtlCol="0" anchor="t"/>
-          <a:lstStyle/>
-          <a:p>
-            <a:pPr indent="0" marL="0">
-              <a:lnSpc>
-                <a:spcPts val="2800"/>
-              </a:lnSpc>
-              <a:buNone/>
-            </a:pPr>
-            <a:r>
-              <a:rPr lang="en-US" sz="2400" b="1" dirty="0">
-                <a:solidFill>
-                  <a:srgbClr val="1E2761"/>
-                </a:solidFill>
-                <a:latin typeface="Cambria" pitchFamily="34" charset="0"/>
-                <a:ea typeface="Cambria" pitchFamily="34" charset="-122"/>
-                <a:cs typeface="Cambria" pitchFamily="34" charset="-120"/>
-              </a:rPr>
-              <a:t>Bigger centres are no safer bet</a:t>
-            </a:r>
-            <a:endParaRPr lang="en-US" sz="2400" dirty="0"/>
-          </a:p>
-        </p:txBody>
-      </p:sp>
-      <p:pic>
-        <p:nvPicPr>
-          <p:cNvPr id="4" name="Image 0" descr="/home/user/Mart/outputs/figures/11_capacity_by_type.png">    </p:cNvPr>
-          <p:cNvPicPr>
-            <a:picLocks noChangeAspect="1"/>
-          </p:cNvPicPr>
-          <p:nvPr/>
-        </p:nvPicPr>
-        <p:blipFill>
-          <a:blip r:embed="rId1"/>
-          <a:stretch>
-            <a:fillRect/>
-          </a:stretch>
-        </p:blipFill>
-        <p:spPr>
-          <a:xfrm>
-            <a:off x="2542157" y="1783080"/>
-            <a:ext cx="7107382" cy="4343400"/>
-          </a:xfrm>
-          <a:prstGeom prst="rect">
-            <a:avLst/>
-          </a:prstGeom>
-          <a:effectLst>
-            <a:outerShdw sx="100000" sy="100000" kx="0" ky="0" algn="bl" rotWithShape="0" blurRad="101600" dist="38100" dir="5400000">
-              <a:srgbClr val="0F1533">
-                <a:alpha val="35000"/>
-              </a:srgbClr>
-            </a:outerShdw>
-          </a:effectLst>
-        </p:spPr>
-      </p:pic>
-      <p:sp>
-        <p:nvSpPr>
-          <p:cNvPr id="5" name="Text 2"/>
           <p:cNvSpPr txBox="1"/>
           <p:nvPr/>
         </p:nvSpPr>
@@ -4108,7 +4267,7 @@
                 <a:ea typeface="Calibri" pitchFamily="34" charset="-122"/>
                 <a:cs typeface="Calibri" pitchFamily="34" charset="-120"/>
               </a:rPr>
-              <a:t>PROBLEM 3 · CHART 12</a:t>
+              <a:t>PROBLEM 3 · CHART 11</a:t>
             </a:r>
             <a:endParaRPr lang="en-US" sz="1300" dirty="0"/>
           </a:p>
@@ -4150,7 +4309,7 @@
                 <a:ea typeface="Cambria" pitchFamily="34" charset="-122"/>
                 <a:cs typeface="Cambria" pitchFamily="34" charset="-120"/>
               </a:rPr>
-              <a:t>Newer services haven't had time to embed practice</a:t>
+              <a:t>Bigger centres are no safer bet</a:t>
             </a:r>
             <a:endParaRPr lang="en-US" sz="2400" dirty="0"/>
           </a:p>
@@ -4158,7 +4317,7 @@
       </p:sp>
       <p:pic>
         <p:nvPicPr>
-          <p:cNvPr id="4" name="Image 0" descr="/home/user/Mart/outputs/figures/12_approval_trend.png">    </p:cNvPr>
+          <p:cNvPr id="4" name="Image 0" descr="/tmp/claude-0/-home-user-Mart/76d1eb32-37a9-556d-8be9-05e0ce1a5b50/scratchpad/deck/clean_charts/11_capacity_by_type.png">    </p:cNvPr>
           <p:cNvPicPr>
             <a:picLocks noChangeAspect="1"/>
           </p:cNvPicPr>
@@ -4172,8 +4331,8 @@
         </p:blipFill>
         <p:spPr>
           <a:xfrm>
-            <a:off x="666598" y="1783080"/>
-            <a:ext cx="10858500" cy="4343400"/>
+            <a:off x="2535223" y="1783080"/>
+            <a:ext cx="7121249" cy="4343400"/>
           </a:xfrm>
           <a:prstGeom prst="rect">
             <a:avLst/>
@@ -4291,7 +4450,7 @@
                 <a:ea typeface="Calibri" pitchFamily="34" charset="-122"/>
                 <a:cs typeface="Calibri" pitchFamily="34" charset="-120"/>
               </a:rPr>
-              <a:t>PROBLEM 3 · CHART 13</a:t>
+              <a:t>PROBLEM 3 · CHART 12</a:t>
             </a:r>
             <a:endParaRPr lang="en-US" sz="1300" dirty="0"/>
           </a:p>
@@ -4333,7 +4492,7 @@
                 <a:ea typeface="Cambria" pitchFamily="34" charset="-122"/>
                 <a:cs typeface="Cambria" pitchFamily="34" charset="-120"/>
               </a:rPr>
-              <a:t>Longer hours, sharply higher non-compliance</a:t>
+              <a:t>Newer services haven't had time to embed practice</a:t>
             </a:r>
             <a:endParaRPr lang="en-US" sz="2400" dirty="0"/>
           </a:p>
@@ -4341,7 +4500,7 @@
       </p:sp>
       <p:pic>
         <p:nvPicPr>
-          <p:cNvPr id="4" name="Image 0" descr="/home/user/Mart/outputs/figures/13_hours_vs_quality.png">    </p:cNvPr>
+          <p:cNvPr id="4" name="Image 0" descr="/tmp/claude-0/-home-user-Mart/76d1eb32-37a9-556d-8be9-05e0ce1a5b50/scratchpad/deck/clean_charts/12_approval_trend.png">    </p:cNvPr>
           <p:cNvPicPr>
             <a:picLocks noChangeAspect="1"/>
           </p:cNvPicPr>
@@ -4355,8 +4514,8 @@
         </p:blipFill>
         <p:spPr>
           <a:xfrm>
-            <a:off x="2186788" y="1783080"/>
-            <a:ext cx="7818120" cy="4343400"/>
+            <a:off x="640080" y="1788582"/>
+            <a:ext cx="10911535" cy="4332397"/>
           </a:xfrm>
           <a:prstGeom prst="rect">
             <a:avLst/>
@@ -4423,7 +4582,7 @@
     <p:bg>
       <p:bgPr>
         <a:solidFill>
-          <a:srgbClr val="1E2761"/>
+          <a:srgbClr val="FFFFFF"/>
         </a:solidFill>
       </p:bgPr>
     </p:bg>
@@ -4449,7 +4608,7 @@
         </p:nvSpPr>
         <p:spPr>
           <a:xfrm>
-            <a:off x="640080" y="502920"/>
+            <a:off x="640080" y="457200"/>
             <a:ext cx="7315200" cy="320040"/>
           </a:xfrm>
           <a:prstGeom prst="rect">
@@ -4474,7 +4633,7 @@
                 <a:ea typeface="Calibri" pitchFamily="34" charset="-122"/>
                 <a:cs typeface="Calibri" pitchFamily="34" charset="-120"/>
               </a:rPr>
-              <a:t>THE DECISION</a:t>
+              <a:t>PROBLEM 3 · CHART 13</a:t>
             </a:r>
             <a:endParaRPr lang="en-US" sz="1300" dirty="0"/>
           </a:p>
@@ -4488,739 +4647,74 @@
         </p:nvSpPr>
         <p:spPr>
           <a:xfrm>
-            <a:off x="640080" y="822960"/>
-            <a:ext cx="10515600" cy="731520"/>
-          </a:xfrm>
-          <a:prstGeom prst="rect">
-            <a:avLst/>
-          </a:prstGeom>
-          <a:noFill/>
-          <a:ln/>
-        </p:spPr>
-        <p:txBody>
-          <a:bodyPr wrap="square" lIns="0" tIns="0" rIns="0" bIns="0" rtlCol="0" anchor="ctr"/>
+            <a:off x="640080" y="731520"/>
+            <a:ext cx="10911535" cy="960120"/>
+          </a:xfrm>
+          <a:prstGeom prst="rect">
+            <a:avLst/>
+          </a:prstGeom>
+          <a:noFill/>
+          <a:ln/>
+        </p:spPr>
+        <p:txBody>
+          <a:bodyPr wrap="square" lIns="0" tIns="0" rIns="0" bIns="0" rtlCol="0" anchor="t"/>
           <a:lstStyle/>
           <a:p>
             <a:pPr indent="0" marL="0">
-              <a:buNone/>
-            </a:pPr>
-            <a:r>
-              <a:rPr lang="en-US" sz="3000" b="1" dirty="0">
-                <a:solidFill>
-                  <a:srgbClr val="FFFFFF"/>
+              <a:lnSpc>
+                <a:spcPts val="2800"/>
+              </a:lnSpc>
+              <a:buNone/>
+            </a:pPr>
+            <a:r>
+              <a:rPr lang="en-US" sz="2400" b="1" dirty="0">
+                <a:solidFill>
+                  <a:srgbClr val="1E2761"/>
                 </a:solidFill>
                 <a:latin typeface="Cambria" pitchFamily="34" charset="0"/>
                 <a:ea typeface="Cambria" pitchFamily="34" charset="-122"/>
                 <a:cs typeface="Cambria" pitchFamily="34" charset="-120"/>
               </a:rPr>
-              <a:t>Four budget lines, four reasons</a:t>
-            </a:r>
-            <a:endParaRPr lang="en-US" sz="3000" dirty="0"/>
-          </a:p>
-        </p:txBody>
-      </p:sp>
-      <p:sp>
-        <p:nvSpPr>
-          <p:cNvPr id="4" name="Shape 2"/>
-          <p:cNvSpPr/>
-          <p:nvPr/>
-        </p:nvSpPr>
-        <p:spPr>
-          <a:xfrm>
-            <a:off x="640080" y="1874520"/>
-            <a:ext cx="5074920" cy="1965960"/>
-          </a:xfrm>
-          <a:prstGeom prst="roundRect">
-            <a:avLst>
-              <a:gd name="adj" fmla="val 4651"/>
-            </a:avLst>
-          </a:prstGeom>
-          <a:solidFill>
-            <a:srgbClr val="141B4D"/>
-          </a:solidFill>
-          <a:ln/>
-        </p:spPr>
-      </p:sp>
-      <p:sp>
-        <p:nvSpPr>
-          <p:cNvPr id="5" name="Shape 3"/>
-          <p:cNvSpPr/>
-          <p:nvPr/>
-        </p:nvSpPr>
-        <p:spPr>
-          <a:xfrm>
-            <a:off x="914400" y="2148840"/>
-            <a:ext cx="502920" cy="502920"/>
-          </a:xfrm>
-          <a:prstGeom prst="ellipse">
-            <a:avLst/>
-          </a:prstGeom>
-          <a:solidFill>
-            <a:srgbClr val="E34948"/>
-          </a:solidFill>
-          <a:ln/>
-        </p:spPr>
-      </p:sp>
-      <p:sp>
-        <p:nvSpPr>
-          <p:cNvPr id="6" name="Text 4"/>
-          <p:cNvSpPr txBox="1"/>
-          <p:nvPr/>
-        </p:nvSpPr>
-        <p:spPr>
-          <a:xfrm>
-            <a:off x="914400" y="2148840"/>
-            <a:ext cx="502920" cy="502920"/>
-          </a:xfrm>
-          <a:prstGeom prst="rect">
-            <a:avLst/>
-          </a:prstGeom>
-          <a:noFill/>
-          <a:ln/>
-        </p:spPr>
-        <p:txBody>
-          <a:bodyPr wrap="square" lIns="0" tIns="0" rIns="0" bIns="0" rtlCol="0" anchor="ctr"/>
-          <a:lstStyle/>
-          <a:p>
-            <a:pPr algn="ctr" indent="0" marL="0">
-              <a:buNone/>
-            </a:pPr>
-            <a:r>
-              <a:rPr lang="en-US" sz="2000" b="1" dirty="0">
-                <a:solidFill>
-                  <a:srgbClr val="FFFFFF"/>
-                </a:solidFill>
-                <a:latin typeface="Cambria" pitchFamily="34" charset="0"/>
-                <a:ea typeface="Cambria" pitchFamily="34" charset="-122"/>
-                <a:cs typeface="Cambria" pitchFamily="34" charset="-120"/>
-              </a:rPr>
-              <a:t>1</a:t>
-            </a:r>
-            <a:endParaRPr lang="en-US" sz="2000" dirty="0"/>
-          </a:p>
-        </p:txBody>
-      </p:sp>
-      <p:sp>
-        <p:nvSpPr>
-          <p:cNvPr id="7" name="Text 5"/>
-          <p:cNvSpPr txBox="1"/>
-          <p:nvPr/>
-        </p:nvSpPr>
-        <p:spPr>
-          <a:xfrm>
-            <a:off x="1600200" y="2075688"/>
-            <a:ext cx="3840480" cy="731520"/>
-          </a:xfrm>
-          <a:prstGeom prst="rect">
-            <a:avLst/>
-          </a:prstGeom>
-          <a:noFill/>
-          <a:ln/>
-        </p:spPr>
-        <p:txBody>
-          <a:bodyPr wrap="square" lIns="0" tIns="0" rIns="0" bIns="0" rtlCol="0" anchor="t"/>
-          <a:lstStyle/>
-          <a:p>
-            <a:pPr indent="0" marL="0">
-              <a:lnSpc>
-                <a:spcPts val="1700"/>
-              </a:lnSpc>
-              <a:buNone/>
-            </a:pPr>
-            <a:r>
-              <a:rPr lang="en-US" sz="1450" b="1" dirty="0">
-                <a:solidFill>
-                  <a:srgbClr val="FFFFFF"/>
-                </a:solidFill>
-                <a:latin typeface="Cambria" pitchFamily="34" charset="0"/>
-                <a:ea typeface="Cambria" pitchFamily="34" charset="-122"/>
-                <a:cs typeface="Cambria" pitchFamily="34" charset="-120"/>
-              </a:rPr>
-              <a:t>Urgent compliance intervention in the NT</a:t>
-            </a:r>
-            <a:endParaRPr lang="en-US" sz="1450" dirty="0"/>
-          </a:p>
-        </p:txBody>
-      </p:sp>
-      <p:sp>
-        <p:nvSpPr>
-          <p:cNvPr id="8" name="Text 6"/>
-          <p:cNvSpPr txBox="1"/>
-          <p:nvPr/>
-        </p:nvSpPr>
-        <p:spPr>
-          <a:xfrm>
-            <a:off x="914400" y="2898648"/>
-            <a:ext cx="4526280" cy="758952"/>
-          </a:xfrm>
-          <a:prstGeom prst="rect">
-            <a:avLst/>
-          </a:prstGeom>
-          <a:noFill/>
-          <a:ln/>
-        </p:spPr>
-        <p:txBody>
-          <a:bodyPr wrap="square" lIns="0" tIns="0" rIns="0" bIns="0" rtlCol="0" anchor="t"/>
-          <a:lstStyle/>
-          <a:p>
-            <a:pPr indent="0" marL="0">
-              <a:lnSpc>
-                <a:spcPts val="1500"/>
-              </a:lnSpc>
-              <a:buNone/>
-            </a:pPr>
-            <a:r>
-              <a:rPr lang="en-US" sz="1200" dirty="0">
-                <a:solidFill>
-                  <a:srgbClr val="CADCFC"/>
-                </a:solidFill>
-                <a:latin typeface="Calibri" pitchFamily="34" charset="0"/>
-                <a:ea typeface="Calibri" pitchFamily="34" charset="-122"/>
-                <a:cs typeface="Calibri" pitchFamily="34" charset="-120"/>
-              </a:rPr>
-              <a:t>Educational program &amp; governance — a legal-minimum problem, not a generic audit. Tasmania, SA and WA aren't far behind.</a:t>
-            </a:r>
-            <a:endParaRPr lang="en-US" sz="1200" dirty="0"/>
-          </a:p>
-        </p:txBody>
-      </p:sp>
-      <p:sp>
-        <p:nvSpPr>
-          <p:cNvPr id="9" name="Shape 7"/>
-          <p:cNvSpPr/>
-          <p:nvPr/>
-        </p:nvSpPr>
-        <p:spPr>
-          <a:xfrm>
-            <a:off x="6080760" y="1874520"/>
-            <a:ext cx="5074920" cy="1965960"/>
-          </a:xfrm>
-          <a:prstGeom prst="roundRect">
-            <a:avLst>
-              <a:gd name="adj" fmla="val 4651"/>
-            </a:avLst>
-          </a:prstGeom>
-          <a:solidFill>
-            <a:srgbClr val="141B4D"/>
-          </a:solidFill>
-          <a:ln/>
-        </p:spPr>
-      </p:sp>
-      <p:sp>
-        <p:nvSpPr>
-          <p:cNvPr id="10" name="Shape 8"/>
-          <p:cNvSpPr/>
-          <p:nvPr/>
-        </p:nvSpPr>
-        <p:spPr>
-          <a:xfrm>
-            <a:off x="6355080" y="2148840"/>
-            <a:ext cx="502920" cy="502920"/>
-          </a:xfrm>
-          <a:prstGeom prst="ellipse">
-            <a:avLst/>
-          </a:prstGeom>
-          <a:solidFill>
-            <a:srgbClr val="E34948"/>
-          </a:solidFill>
-          <a:ln/>
-        </p:spPr>
-      </p:sp>
-      <p:sp>
-        <p:nvSpPr>
-          <p:cNvPr id="11" name="Text 9"/>
-          <p:cNvSpPr txBox="1"/>
-          <p:nvPr/>
-        </p:nvSpPr>
-        <p:spPr>
-          <a:xfrm>
-            <a:off x="6355080" y="2148840"/>
-            <a:ext cx="502920" cy="502920"/>
-          </a:xfrm>
-          <a:prstGeom prst="rect">
-            <a:avLst/>
-          </a:prstGeom>
-          <a:noFill/>
-          <a:ln/>
-        </p:spPr>
-        <p:txBody>
-          <a:bodyPr wrap="square" lIns="0" tIns="0" rIns="0" bIns="0" rtlCol="0" anchor="ctr"/>
-          <a:lstStyle/>
-          <a:p>
-            <a:pPr algn="ctr" indent="0" marL="0">
-              <a:buNone/>
-            </a:pPr>
-            <a:r>
-              <a:rPr lang="en-US" sz="2000" b="1" dirty="0">
-                <a:solidFill>
-                  <a:srgbClr val="FFFFFF"/>
-                </a:solidFill>
-                <a:latin typeface="Cambria" pitchFamily="34" charset="0"/>
-                <a:ea typeface="Cambria" pitchFamily="34" charset="-122"/>
-                <a:cs typeface="Cambria" pitchFamily="34" charset="-120"/>
-              </a:rPr>
-              <a:t>2</a:t>
-            </a:r>
-            <a:endParaRPr lang="en-US" sz="2000" dirty="0"/>
-          </a:p>
-        </p:txBody>
-      </p:sp>
-      <p:sp>
-        <p:nvSpPr>
-          <p:cNvPr id="12" name="Text 10"/>
-          <p:cNvSpPr txBox="1"/>
-          <p:nvPr/>
-        </p:nvSpPr>
-        <p:spPr>
-          <a:xfrm>
-            <a:off x="7040880" y="2075688"/>
-            <a:ext cx="3840480" cy="731520"/>
-          </a:xfrm>
-          <a:prstGeom prst="rect">
-            <a:avLst/>
-          </a:prstGeom>
-          <a:noFill/>
-          <a:ln/>
-        </p:spPr>
-        <p:txBody>
-          <a:bodyPr wrap="square" lIns="0" tIns="0" rIns="0" bIns="0" rtlCol="0" anchor="t"/>
-          <a:lstStyle/>
-          <a:p>
-            <a:pPr indent="0" marL="0">
-              <a:lnSpc>
-                <a:spcPts val="1700"/>
-              </a:lnSpc>
-              <a:buNone/>
-            </a:pPr>
-            <a:r>
-              <a:rPr lang="en-US" sz="1450" b="1" dirty="0">
-                <a:solidFill>
-                  <a:srgbClr val="FFFFFF"/>
-                </a:solidFill>
-                <a:latin typeface="Cambria" pitchFamily="34" charset="0"/>
-                <a:ea typeface="Cambria" pitchFamily="34" charset="-122"/>
-                <a:cs typeface="Cambria" pitchFamily="34" charset="-120"/>
-              </a:rPr>
-              <a:t>New-service funding, named destinations</a:t>
-            </a:r>
-            <a:endParaRPr lang="en-US" sz="1450" dirty="0"/>
-          </a:p>
-        </p:txBody>
-      </p:sp>
-      <p:sp>
-        <p:nvSpPr>
-          <p:cNvPr id="13" name="Text 11"/>
-          <p:cNvSpPr txBox="1"/>
-          <p:nvPr/>
-        </p:nvSpPr>
-        <p:spPr>
-          <a:xfrm>
-            <a:off x="6355080" y="2898648"/>
-            <a:ext cx="4526280" cy="758952"/>
-          </a:xfrm>
-          <a:prstGeom prst="rect">
-            <a:avLst/>
-          </a:prstGeom>
-          <a:noFill/>
-          <a:ln/>
-        </p:spPr>
-        <p:txBody>
-          <a:bodyPr wrap="square" lIns="0" tIns="0" rIns="0" bIns="0" rtlCol="0" anchor="t"/>
-          <a:lstStyle/>
-          <a:p>
-            <a:pPr indent="0" marL="0">
-              <a:lnSpc>
-                <a:spcPts val="1500"/>
-              </a:lnSpc>
-              <a:buNone/>
-            </a:pPr>
-            <a:r>
-              <a:rPr lang="en-US" sz="1200" dirty="0">
-                <a:solidFill>
-                  <a:srgbClr val="CADCFC"/>
-                </a:solidFill>
-                <a:latin typeface="Calibri" pitchFamily="34" charset="0"/>
-                <a:ea typeface="Calibri" pitchFamily="34" charset="-122"/>
-                <a:cs typeface="Calibri" pitchFamily="34" charset="-120"/>
-              </a:rPr>
-              <a:t>WA's and the NT's Bounded Localities — 41km and 30km to a family's nearest backup option.</a:t>
-            </a:r>
-            <a:endParaRPr lang="en-US" sz="1200" dirty="0"/>
-          </a:p>
-        </p:txBody>
-      </p:sp>
-      <p:sp>
-        <p:nvSpPr>
-          <p:cNvPr id="14" name="Shape 12"/>
-          <p:cNvSpPr/>
-          <p:nvPr/>
-        </p:nvSpPr>
-        <p:spPr>
-          <a:xfrm>
-            <a:off x="640080" y="4114800"/>
-            <a:ext cx="5074920" cy="1965960"/>
-          </a:xfrm>
-          <a:prstGeom prst="roundRect">
-            <a:avLst>
-              <a:gd name="adj" fmla="val 4651"/>
-            </a:avLst>
-          </a:prstGeom>
-          <a:solidFill>
-            <a:srgbClr val="141B4D"/>
-          </a:solidFill>
-          <a:ln/>
-        </p:spPr>
-      </p:sp>
-      <p:sp>
-        <p:nvSpPr>
-          <p:cNvPr id="15" name="Shape 13"/>
-          <p:cNvSpPr/>
-          <p:nvPr/>
-        </p:nvSpPr>
-        <p:spPr>
-          <a:xfrm>
-            <a:off x="914400" y="4389120"/>
-            <a:ext cx="502920" cy="502920"/>
-          </a:xfrm>
-          <a:prstGeom prst="ellipse">
-            <a:avLst/>
-          </a:prstGeom>
-          <a:solidFill>
-            <a:srgbClr val="E34948"/>
-          </a:solidFill>
-          <a:ln/>
-        </p:spPr>
-      </p:sp>
-      <p:sp>
-        <p:nvSpPr>
-          <p:cNvPr id="16" name="Text 14"/>
-          <p:cNvSpPr txBox="1"/>
-          <p:nvPr/>
-        </p:nvSpPr>
-        <p:spPr>
-          <a:xfrm>
-            <a:off x="914400" y="4389120"/>
-            <a:ext cx="502920" cy="502920"/>
-          </a:xfrm>
-          <a:prstGeom prst="rect">
-            <a:avLst/>
-          </a:prstGeom>
-          <a:noFill/>
-          <a:ln/>
-        </p:spPr>
-        <p:txBody>
-          <a:bodyPr wrap="square" lIns="0" tIns="0" rIns="0" bIns="0" rtlCol="0" anchor="ctr"/>
-          <a:lstStyle/>
-          <a:p>
-            <a:pPr algn="ctr" indent="0" marL="0">
-              <a:buNone/>
-            </a:pPr>
-            <a:r>
-              <a:rPr lang="en-US" sz="2000" b="1" dirty="0">
-                <a:solidFill>
-                  <a:srgbClr val="FFFFFF"/>
-                </a:solidFill>
-                <a:latin typeface="Cambria" pitchFamily="34" charset="0"/>
-                <a:ea typeface="Cambria" pitchFamily="34" charset="-122"/>
-                <a:cs typeface="Cambria" pitchFamily="34" charset="-120"/>
-              </a:rPr>
-              <a:t>3</a:t>
-            </a:r>
-            <a:endParaRPr lang="en-US" sz="2000" dirty="0"/>
-          </a:p>
-        </p:txBody>
-      </p:sp>
-      <p:sp>
-        <p:nvSpPr>
-          <p:cNvPr id="17" name="Text 15"/>
-          <p:cNvSpPr txBox="1"/>
-          <p:nvPr/>
-        </p:nvSpPr>
-        <p:spPr>
-          <a:xfrm>
-            <a:off x="1600200" y="4315968"/>
-            <a:ext cx="3840480" cy="731520"/>
-          </a:xfrm>
-          <a:prstGeom prst="rect">
-            <a:avLst/>
-          </a:prstGeom>
-          <a:noFill/>
-          <a:ln/>
-        </p:spPr>
-        <p:txBody>
-          <a:bodyPr wrap="square" lIns="0" tIns="0" rIns="0" bIns="0" rtlCol="0" anchor="t"/>
-          <a:lstStyle/>
-          <a:p>
-            <a:pPr indent="0" marL="0">
-              <a:lnSpc>
-                <a:spcPts val="1700"/>
-              </a:lnSpc>
-              <a:buNone/>
-            </a:pPr>
-            <a:r>
-              <a:rPr lang="en-US" sz="1450" b="1" dirty="0">
-                <a:solidFill>
-                  <a:srgbClr val="FFFFFF"/>
-                </a:solidFill>
-                <a:latin typeface="Cambria" pitchFamily="34" charset="0"/>
-                <a:ea typeface="Cambria" pitchFamily="34" charset="-122"/>
-                <a:cs typeface="Cambria" pitchFamily="34" charset="-120"/>
-              </a:rPr>
-              <a:t>Transport as a rural equity investment</a:t>
-            </a:r>
-            <a:endParaRPr lang="en-US" sz="1450" dirty="0"/>
-          </a:p>
-        </p:txBody>
-      </p:sp>
-      <p:sp>
-        <p:nvSpPr>
-          <p:cNvPr id="18" name="Text 16"/>
-          <p:cNvSpPr txBox="1"/>
-          <p:nvPr/>
-        </p:nvSpPr>
-        <p:spPr>
-          <a:xfrm>
-            <a:off x="914400" y="5138928"/>
-            <a:ext cx="4526280" cy="758952"/>
-          </a:xfrm>
-          <a:prstGeom prst="rect">
-            <a:avLst/>
-          </a:prstGeom>
-          <a:noFill/>
-          <a:ln/>
-        </p:spPr>
-        <p:txBody>
-          <a:bodyPr wrap="square" lIns="0" tIns="0" rIns="0" bIns="0" rtlCol="0" anchor="t"/>
-          <a:lstStyle/>
-          <a:p>
-            <a:pPr indent="0" marL="0">
-              <a:lnSpc>
-                <a:spcPts val="1500"/>
-              </a:lnSpc>
-              <a:buNone/>
-            </a:pPr>
-            <a:r>
-              <a:rPr lang="en-US" sz="1200" dirty="0">
-                <a:solidFill>
-                  <a:srgbClr val="CADCFC"/>
-                </a:solidFill>
-                <a:latin typeface="Calibri" pitchFamily="34" charset="0"/>
-                <a:ea typeface="Calibri" pitchFamily="34" charset="-122"/>
-                <a:cs typeface="Calibri" pitchFamily="34" charset="-120"/>
-              </a:rPr>
-              <a:t>Real but small as a quality lever — fund it for equity, not as a compliance play.</a:t>
-            </a:r>
-            <a:endParaRPr lang="en-US" sz="1200" dirty="0"/>
-          </a:p>
-        </p:txBody>
-      </p:sp>
-      <p:sp>
-        <p:nvSpPr>
-          <p:cNvPr id="19" name="Shape 17"/>
-          <p:cNvSpPr/>
-          <p:nvPr/>
-        </p:nvSpPr>
-        <p:spPr>
-          <a:xfrm>
-            <a:off x="6080760" y="4114800"/>
-            <a:ext cx="5074920" cy="1965960"/>
-          </a:xfrm>
-          <a:prstGeom prst="roundRect">
-            <a:avLst>
-              <a:gd name="adj" fmla="val 4651"/>
-            </a:avLst>
-          </a:prstGeom>
-          <a:solidFill>
-            <a:srgbClr val="141B4D"/>
-          </a:solidFill>
-          <a:ln/>
-        </p:spPr>
-      </p:sp>
-      <p:sp>
-        <p:nvSpPr>
-          <p:cNvPr id="20" name="Shape 18"/>
-          <p:cNvSpPr/>
-          <p:nvPr/>
-        </p:nvSpPr>
-        <p:spPr>
-          <a:xfrm>
-            <a:off x="6355080" y="4389120"/>
-            <a:ext cx="502920" cy="502920"/>
-          </a:xfrm>
-          <a:prstGeom prst="ellipse">
-            <a:avLst/>
-          </a:prstGeom>
-          <a:solidFill>
-            <a:srgbClr val="E34948"/>
-          </a:solidFill>
-          <a:ln/>
-        </p:spPr>
-      </p:sp>
-      <p:sp>
-        <p:nvSpPr>
-          <p:cNvPr id="21" name="Text 19"/>
-          <p:cNvSpPr txBox="1"/>
-          <p:nvPr/>
-        </p:nvSpPr>
-        <p:spPr>
-          <a:xfrm>
-            <a:off x="6355080" y="4389120"/>
-            <a:ext cx="502920" cy="502920"/>
-          </a:xfrm>
-          <a:prstGeom prst="rect">
-            <a:avLst/>
-          </a:prstGeom>
-          <a:noFill/>
-          <a:ln/>
-        </p:spPr>
-        <p:txBody>
-          <a:bodyPr wrap="square" lIns="0" tIns="0" rIns="0" bIns="0" rtlCol="0" anchor="ctr"/>
-          <a:lstStyle/>
-          <a:p>
-            <a:pPr algn="ctr" indent="0" marL="0">
-              <a:buNone/>
-            </a:pPr>
-            <a:r>
-              <a:rPr lang="en-US" sz="2000" b="1" dirty="0">
-                <a:solidFill>
-                  <a:srgbClr val="FFFFFF"/>
-                </a:solidFill>
-                <a:latin typeface="Cambria" pitchFamily="34" charset="0"/>
-                <a:ea typeface="Cambria" pitchFamily="34" charset="-122"/>
-                <a:cs typeface="Cambria" pitchFamily="34" charset="-120"/>
-              </a:rPr>
-              <a:t>4</a:t>
-            </a:r>
-            <a:endParaRPr lang="en-US" sz="2000" dirty="0"/>
-          </a:p>
-        </p:txBody>
-      </p:sp>
-      <p:sp>
-        <p:nvSpPr>
-          <p:cNvPr id="22" name="Text 20"/>
-          <p:cNvSpPr txBox="1"/>
-          <p:nvPr/>
-        </p:nvSpPr>
-        <p:spPr>
-          <a:xfrm>
-            <a:off x="7040880" y="4315968"/>
-            <a:ext cx="3840480" cy="731520"/>
-          </a:xfrm>
-          <a:prstGeom prst="rect">
-            <a:avLst/>
-          </a:prstGeom>
-          <a:noFill/>
-          <a:ln/>
-        </p:spPr>
-        <p:txBody>
-          <a:bodyPr wrap="square" lIns="0" tIns="0" rIns="0" bIns="0" rtlCol="0" anchor="t"/>
-          <a:lstStyle/>
-          <a:p>
-            <a:pPr indent="0" marL="0">
-              <a:lnSpc>
-                <a:spcPts val="1700"/>
-              </a:lnSpc>
-              <a:buNone/>
-            </a:pPr>
-            <a:r>
-              <a:rPr lang="en-US" sz="1450" b="1" dirty="0">
-                <a:solidFill>
-                  <a:srgbClr val="FFFFFF"/>
-                </a:solidFill>
-                <a:latin typeface="Cambria" pitchFamily="34" charset="0"/>
-                <a:ea typeface="Cambria" pitchFamily="34" charset="-122"/>
-                <a:cs typeface="Cambria" pitchFamily="34" charset="-120"/>
-              </a:rPr>
-              <a:t>A support pathway for newly-approved services</a:t>
-            </a:r>
-            <a:endParaRPr lang="en-US" sz="1450" dirty="0"/>
-          </a:p>
-        </p:txBody>
-      </p:sp>
-      <p:sp>
-        <p:nvSpPr>
-          <p:cNvPr id="23" name="Text 21"/>
-          <p:cNvSpPr txBox="1"/>
-          <p:nvPr/>
-        </p:nvSpPr>
-        <p:spPr>
-          <a:xfrm>
-            <a:off x="6355080" y="5138928"/>
-            <a:ext cx="4526280" cy="758952"/>
-          </a:xfrm>
-          <a:prstGeom prst="rect">
-            <a:avLst/>
-          </a:prstGeom>
-          <a:noFill/>
-          <a:ln/>
-        </p:spPr>
-        <p:txBody>
-          <a:bodyPr wrap="square" lIns="0" tIns="0" rIns="0" bIns="0" rtlCol="0" anchor="t"/>
-          <a:lstStyle/>
-          <a:p>
-            <a:pPr indent="0" marL="0">
-              <a:lnSpc>
-                <a:spcPts val="1500"/>
-              </a:lnSpc>
-              <a:buNone/>
-            </a:pPr>
-            <a:r>
-              <a:rPr lang="en-US" sz="1200" dirty="0">
-                <a:solidFill>
-                  <a:srgbClr val="CADCFC"/>
-                </a:solidFill>
-                <a:latin typeface="Calibri" pitchFamily="34" charset="0"/>
-                <a:ea typeface="Calibri" pitchFamily="34" charset="-122"/>
-                <a:cs typeface="Calibri" pitchFamily="34" charset="-120"/>
-              </a:rPr>
-              <a:t>Not a compliance one — they just haven't had the years yet.</a:t>
-            </a:r>
-            <a:endParaRPr lang="en-US" sz="1200" dirty="0"/>
-          </a:p>
-        </p:txBody>
-      </p:sp>
-      <p:sp>
-        <p:nvSpPr>
-          <p:cNvPr id="24" name="Text 22"/>
-          <p:cNvSpPr txBox="1"/>
-          <p:nvPr/>
-        </p:nvSpPr>
-        <p:spPr>
-          <a:xfrm>
-            <a:off x="640080" y="6172200"/>
-            <a:ext cx="7315200" cy="365760"/>
-          </a:xfrm>
-          <a:prstGeom prst="rect">
-            <a:avLst/>
-          </a:prstGeom>
-          <a:noFill/>
-          <a:ln/>
-        </p:spPr>
-        <p:txBody>
-          <a:bodyPr wrap="square" lIns="0" tIns="0" rIns="0" bIns="0" rtlCol="0" anchor="ctr"/>
-          <a:lstStyle/>
-          <a:p>
-            <a:pPr indent="0" marL="0">
-              <a:buNone/>
-            </a:pPr>
-            <a:r>
-              <a:rPr lang="en-US" sz="1400" i="1" dirty="0">
-                <a:solidFill>
-                  <a:srgbClr val="CADCFC"/>
-                </a:solidFill>
-                <a:latin typeface="Calibri" pitchFamily="34" charset="0"/>
-                <a:ea typeface="Calibri" pitchFamily="34" charset="-122"/>
-                <a:cs typeface="Calibri" pitchFamily="34" charset="-120"/>
-              </a:rPr>
-              <a:t>A budget with a reason behind every line.</a:t>
-            </a:r>
-            <a:endParaRPr lang="en-US" sz="1400" dirty="0"/>
-          </a:p>
-        </p:txBody>
-      </p:sp>
-      <p:sp>
-        <p:nvSpPr>
-          <p:cNvPr id="25" name="Text 23"/>
+              <a:t>Longer hours, sharply higher non-compliance</a:t>
+            </a:r>
+            <a:endParaRPr lang="en-US" sz="2400" dirty="0"/>
+          </a:p>
+        </p:txBody>
+      </p:sp>
+      <p:pic>
+        <p:nvPicPr>
+          <p:cNvPr id="4" name="Image 0" descr="/tmp/claude-0/-home-user-Mart/76d1eb32-37a9-556d-8be9-05e0ce1a5b50/scratchpad/deck/clean_charts/13_hours_vs_quality.png">    </p:cNvPr>
+          <p:cNvPicPr>
+            <a:picLocks noChangeAspect="1"/>
+          </p:cNvPicPr>
+          <p:nvPr/>
+        </p:nvPicPr>
+        <p:blipFill>
+          <a:blip r:embed="rId1"/>
+          <a:stretch>
+            <a:fillRect/>
+          </a:stretch>
+        </p:blipFill>
+        <p:spPr>
+          <a:xfrm>
+            <a:off x="2164627" y="1783080"/>
+            <a:ext cx="7862440" cy="4343400"/>
+          </a:xfrm>
+          <a:prstGeom prst="rect">
+            <a:avLst/>
+          </a:prstGeom>
+          <a:effectLst>
+            <a:outerShdw sx="100000" sy="100000" kx="0" ky="0" algn="bl" rotWithShape="0" blurRad="101600" dist="38100" dir="5400000">
+              <a:srgbClr val="0F1533">
+                <a:alpha val="35000"/>
+              </a:srgbClr>
+            </a:outerShdw>
+          </a:effectLst>
+        </p:spPr>
+      </p:pic>
+      <p:sp>
+        <p:nvSpPr>
+          <p:cNvPr id="5" name="Text 2"/>
           <p:cNvSpPr txBox="1"/>
           <p:nvPr/>
         </p:nvSpPr>
@@ -5744,9 +5238,9 @@
 </p:sld>
 </file>
 
-<file path=ppt/slides/slide3.xml><?xml version="1.0" encoding="utf-8"?>
+<file path=ppt/slides/slide20.xml><?xml version="1.0" encoding="utf-8"?>
 <p:sld xmlns:a="http://schemas.openxmlformats.org/drawingml/2006/main" xmlns:r="http://schemas.openxmlformats.org/officeDocument/2006/relationships" xmlns:p="http://schemas.openxmlformats.org/presentationml/2006/main">
-  <p:cSld name="Slide 3">
+  <p:cSld name="Slide 20">
     <p:bg>
       <p:bgPr>
         <a:solidFill>
@@ -5770,14 +5264,114 @@
       </p:grpSpPr>
       <p:sp>
         <p:nvSpPr>
-          <p:cNvPr id="2" name="Shape 0"/>
+          <p:cNvPr id="2" name="Text 0"/>
+          <p:cNvSpPr txBox="1"/>
+          <p:nvPr/>
+        </p:nvSpPr>
+        <p:spPr>
+          <a:xfrm>
+            <a:off x="640080" y="502920"/>
+            <a:ext cx="7315200" cy="320040"/>
+          </a:xfrm>
+          <a:prstGeom prst="rect">
+            <a:avLst/>
+          </a:prstGeom>
+          <a:noFill/>
+          <a:ln/>
+        </p:spPr>
+        <p:txBody>
+          <a:bodyPr wrap="square" lIns="0" tIns="0" rIns="0" bIns="0" rtlCol="0" anchor="ctr"/>
+          <a:lstStyle/>
+          <a:p>
+            <a:pPr indent="0" marL="0">
+              <a:buNone/>
+            </a:pPr>
+            <a:r>
+              <a:rPr lang="en-US" sz="1300" b="1" spc="200" kern="0" dirty="0">
+                <a:solidFill>
+                  <a:srgbClr val="E34948"/>
+                </a:solidFill>
+                <a:latin typeface="Calibri" pitchFamily="34" charset="0"/>
+                <a:ea typeface="Calibri" pitchFamily="34" charset="-122"/>
+                <a:cs typeface="Calibri" pitchFamily="34" charset="-120"/>
+              </a:rPr>
+              <a:t>THE DECISION</a:t>
+            </a:r>
+            <a:endParaRPr lang="en-US" sz="1300" dirty="0"/>
+          </a:p>
+        </p:txBody>
+      </p:sp>
+      <p:sp>
+        <p:nvSpPr>
+          <p:cNvPr id="3" name="Text 1"/>
+          <p:cNvSpPr txBox="1"/>
+          <p:nvPr/>
+        </p:nvSpPr>
+        <p:spPr>
+          <a:xfrm>
+            <a:off x="640080" y="822960"/>
+            <a:ext cx="10515600" cy="731520"/>
+          </a:xfrm>
+          <a:prstGeom prst="rect">
+            <a:avLst/>
+          </a:prstGeom>
+          <a:noFill/>
+          <a:ln/>
+        </p:spPr>
+        <p:txBody>
+          <a:bodyPr wrap="square" lIns="0" tIns="0" rIns="0" bIns="0" rtlCol="0" anchor="ctr"/>
+          <a:lstStyle/>
+          <a:p>
+            <a:pPr indent="0" marL="0">
+              <a:buNone/>
+            </a:pPr>
+            <a:r>
+              <a:rPr lang="en-US" sz="3000" b="1" dirty="0">
+                <a:solidFill>
+                  <a:srgbClr val="FFFFFF"/>
+                </a:solidFill>
+                <a:latin typeface="Cambria" pitchFamily="34" charset="0"/>
+                <a:ea typeface="Cambria" pitchFamily="34" charset="-122"/>
+                <a:cs typeface="Cambria" pitchFamily="34" charset="-120"/>
+              </a:rPr>
+              <a:t>Four budget lines, four reasons</a:t>
+            </a:r>
+            <a:endParaRPr lang="en-US" sz="3000" dirty="0"/>
+          </a:p>
+        </p:txBody>
+      </p:sp>
+      <p:sp>
+        <p:nvSpPr>
+          <p:cNvPr id="4" name="Shape 2"/>
           <p:cNvSpPr/>
           <p:nvPr/>
         </p:nvSpPr>
         <p:spPr>
           <a:xfrm>
-            <a:off x="822960" y="777240"/>
-            <a:ext cx="1051560" cy="1051560"/>
+            <a:off x="640080" y="1874520"/>
+            <a:ext cx="5074920" cy="1965960"/>
+          </a:xfrm>
+          <a:prstGeom prst="roundRect">
+            <a:avLst>
+              <a:gd name="adj" fmla="val 4651"/>
+            </a:avLst>
+          </a:prstGeom>
+          <a:solidFill>
+            <a:srgbClr val="141B4D"/>
+          </a:solidFill>
+          <a:ln/>
+        </p:spPr>
+      </p:sp>
+      <p:sp>
+        <p:nvSpPr>
+          <p:cNvPr id="5" name="Shape 3"/>
+          <p:cNvSpPr/>
+          <p:nvPr/>
+        </p:nvSpPr>
+        <p:spPr>
+          <a:xfrm>
+            <a:off x="914400" y="2148840"/>
+            <a:ext cx="502920" cy="502920"/>
           </a:xfrm>
           <a:prstGeom prst="ellipse">
             <a:avLst/>
@@ -5790,14 +5384,14 @@
       </p:sp>
       <p:sp>
         <p:nvSpPr>
-          <p:cNvPr id="3" name="Text 1"/>
-          <p:cNvSpPr txBox="1"/>
-          <p:nvPr/>
-        </p:nvSpPr>
-        <p:spPr>
-          <a:xfrm>
-            <a:off x="822960" y="777240"/>
-            <a:ext cx="1051560" cy="1051560"/>
+          <p:cNvPr id="6" name="Text 4"/>
+          <p:cNvSpPr txBox="1"/>
+          <p:nvPr/>
+        </p:nvSpPr>
+        <p:spPr>
+          <a:xfrm>
+            <a:off x="914400" y="2148840"/>
+            <a:ext cx="502920" cy="502920"/>
           </a:xfrm>
           <a:prstGeom prst="rect">
             <a:avLst/>
@@ -5813,7 +5407,7 @@
               <a:buNone/>
             </a:pPr>
             <a:r>
-              <a:rPr lang="en-US" sz="3400" b="1" dirty="0">
+              <a:rPr lang="en-US" sz="2000" b="1" dirty="0">
                 <a:solidFill>
                   <a:srgbClr val="FFFFFF"/>
                 </a:solidFill>
@@ -5823,36 +5417,81 @@
               </a:rPr>
               <a:t>1</a:t>
             </a:r>
-            <a:endParaRPr lang="en-US" sz="3400" dirty="0"/>
-          </a:p>
-        </p:txBody>
-      </p:sp>
-      <p:sp>
-        <p:nvSpPr>
-          <p:cNvPr id="4" name="Text 2"/>
-          <p:cNvSpPr txBox="1"/>
-          <p:nvPr/>
-        </p:nvSpPr>
-        <p:spPr>
-          <a:xfrm>
-            <a:off x="2148840" y="1024128"/>
-            <a:ext cx="7315200" cy="320040"/>
-          </a:xfrm>
-          <a:prstGeom prst="rect">
-            <a:avLst/>
-          </a:prstGeom>
-          <a:noFill/>
-          <a:ln/>
-        </p:spPr>
-        <p:txBody>
-          <a:bodyPr wrap="square" lIns="0" tIns="0" rIns="0" bIns="0" rtlCol="0" anchor="ctr"/>
+            <a:endParaRPr lang="en-US" sz="2000" dirty="0"/>
+          </a:p>
+        </p:txBody>
+      </p:sp>
+      <p:sp>
+        <p:nvSpPr>
+          <p:cNvPr id="7" name="Text 5"/>
+          <p:cNvSpPr txBox="1"/>
+          <p:nvPr/>
+        </p:nvSpPr>
+        <p:spPr>
+          <a:xfrm>
+            <a:off x="1600200" y="2075688"/>
+            <a:ext cx="3840480" cy="731520"/>
+          </a:xfrm>
+          <a:prstGeom prst="rect">
+            <a:avLst/>
+          </a:prstGeom>
+          <a:noFill/>
+          <a:ln/>
+        </p:spPr>
+        <p:txBody>
+          <a:bodyPr wrap="square" lIns="0" tIns="0" rIns="0" bIns="0" rtlCol="0" anchor="t"/>
           <a:lstStyle/>
           <a:p>
             <a:pPr indent="0" marL="0">
-              <a:buNone/>
-            </a:pPr>
-            <a:r>
-              <a:rPr lang="en-US" sz="1300" b="1" spc="200" kern="0" dirty="0">
+              <a:lnSpc>
+                <a:spcPts val="1700"/>
+              </a:lnSpc>
+              <a:buNone/>
+            </a:pPr>
+            <a:r>
+              <a:rPr lang="en-US" sz="1450" b="1" dirty="0">
+                <a:solidFill>
+                  <a:srgbClr val="FFFFFF"/>
+                </a:solidFill>
+                <a:latin typeface="Cambria" pitchFamily="34" charset="0"/>
+                <a:ea typeface="Cambria" pitchFamily="34" charset="-122"/>
+                <a:cs typeface="Cambria" pitchFamily="34" charset="-120"/>
+              </a:rPr>
+              <a:t>Urgent compliance intervention in the NT</a:t>
+            </a:r>
+            <a:endParaRPr lang="en-US" sz="1450" dirty="0"/>
+          </a:p>
+        </p:txBody>
+      </p:sp>
+      <p:sp>
+        <p:nvSpPr>
+          <p:cNvPr id="8" name="Text 6"/>
+          <p:cNvSpPr txBox="1"/>
+          <p:nvPr/>
+        </p:nvSpPr>
+        <p:spPr>
+          <a:xfrm>
+            <a:off x="914400" y="2898648"/>
+            <a:ext cx="4526280" cy="758952"/>
+          </a:xfrm>
+          <a:prstGeom prst="rect">
+            <a:avLst/>
+          </a:prstGeom>
+          <a:noFill/>
+          <a:ln/>
+        </p:spPr>
+        <p:txBody>
+          <a:bodyPr wrap="square" lIns="0" tIns="0" rIns="0" bIns="0" rtlCol="0" anchor="t"/>
+          <a:lstStyle/>
+          <a:p>
+            <a:pPr indent="0" marL="0">
+              <a:lnSpc>
+                <a:spcPts val="1500"/>
+              </a:lnSpc>
+              <a:buNone/>
+            </a:pPr>
+            <a:r>
+              <a:rPr lang="en-US" sz="1200" dirty="0">
                 <a:solidFill>
                   <a:srgbClr val="CADCFC"/>
                 </a:solidFill>
@@ -5860,41 +5499,80 @@
                 <a:ea typeface="Calibri" pitchFamily="34" charset="-122"/>
                 <a:cs typeface="Calibri" pitchFamily="34" charset="-120"/>
               </a:rPr>
-              <a:t>PROBLEM 1</a:t>
-            </a:r>
-            <a:endParaRPr lang="en-US" sz="1300" dirty="0"/>
-          </a:p>
-        </p:txBody>
-      </p:sp>
-      <p:sp>
-        <p:nvSpPr>
-          <p:cNvPr id="5" name="Text 3"/>
-          <p:cNvSpPr txBox="1"/>
-          <p:nvPr/>
-        </p:nvSpPr>
-        <p:spPr>
-          <a:xfrm>
-            <a:off x="822960" y="2331720"/>
-            <a:ext cx="9875520" cy="2011680"/>
-          </a:xfrm>
-          <a:prstGeom prst="rect">
-            <a:avLst/>
-          </a:prstGeom>
-          <a:noFill/>
-          <a:ln/>
-        </p:spPr>
-        <p:txBody>
-          <a:bodyPr wrap="square" lIns="0" tIns="0" rIns="0" bIns="0" rtlCol="0" anchor="t"/>
-          <a:lstStyle/>
-          <a:p>
-            <a:pPr indent="0" marL="0">
-              <a:lnSpc>
-                <a:spcPts val="4000"/>
-              </a:lnSpc>
-              <a:buNone/>
-            </a:pPr>
-            <a:r>
-              <a:rPr lang="en-US" sz="3400" b="1" dirty="0">
+              <a:t>Educational program &amp; governance — a legal-minimum problem, not a generic audit. Tasmania, SA and WA aren't far behind.</a:t>
+            </a:r>
+            <a:endParaRPr lang="en-US" sz="1200" dirty="0"/>
+          </a:p>
+        </p:txBody>
+      </p:sp>
+      <p:sp>
+        <p:nvSpPr>
+          <p:cNvPr id="9" name="Shape 7"/>
+          <p:cNvSpPr/>
+          <p:nvPr/>
+        </p:nvSpPr>
+        <p:spPr>
+          <a:xfrm>
+            <a:off x="6080760" y="1874520"/>
+            <a:ext cx="5074920" cy="1965960"/>
+          </a:xfrm>
+          <a:prstGeom prst="roundRect">
+            <a:avLst>
+              <a:gd name="adj" fmla="val 4651"/>
+            </a:avLst>
+          </a:prstGeom>
+          <a:solidFill>
+            <a:srgbClr val="141B4D"/>
+          </a:solidFill>
+          <a:ln/>
+        </p:spPr>
+      </p:sp>
+      <p:sp>
+        <p:nvSpPr>
+          <p:cNvPr id="10" name="Shape 8"/>
+          <p:cNvSpPr/>
+          <p:nvPr/>
+        </p:nvSpPr>
+        <p:spPr>
+          <a:xfrm>
+            <a:off x="6355080" y="2148840"/>
+            <a:ext cx="502920" cy="502920"/>
+          </a:xfrm>
+          <a:prstGeom prst="ellipse">
+            <a:avLst/>
+          </a:prstGeom>
+          <a:solidFill>
+            <a:srgbClr val="E34948"/>
+          </a:solidFill>
+          <a:ln/>
+        </p:spPr>
+      </p:sp>
+      <p:sp>
+        <p:nvSpPr>
+          <p:cNvPr id="11" name="Text 9"/>
+          <p:cNvSpPr txBox="1"/>
+          <p:nvPr/>
+        </p:nvSpPr>
+        <p:spPr>
+          <a:xfrm>
+            <a:off x="6355080" y="2148840"/>
+            <a:ext cx="502920" cy="502920"/>
+          </a:xfrm>
+          <a:prstGeom prst="rect">
+            <a:avLst/>
+          </a:prstGeom>
+          <a:noFill/>
+          <a:ln/>
+        </p:spPr>
+        <p:txBody>
+          <a:bodyPr wrap="square" lIns="0" tIns="0" rIns="0" bIns="0" rtlCol="0" anchor="ctr"/>
+          <a:lstStyle/>
+          <a:p>
+            <a:pPr algn="ctr" indent="0" marL="0">
+              <a:buNone/>
+            </a:pPr>
+            <a:r>
+              <a:rPr lang="en-US" sz="2000" b="1" dirty="0">
                 <a:solidFill>
                   <a:srgbClr val="FFFFFF"/>
                 </a:solidFill>
@@ -5902,41 +5580,83 @@
                 <a:ea typeface="Cambria" pitchFamily="34" charset="-122"/>
                 <a:cs typeface="Cambria" pitchFamily="34" charset="-120"/>
               </a:rPr>
-              <a:t>Is quality failing consistently, or is it a specific, fixable issue?</a:t>
-            </a:r>
-            <a:endParaRPr lang="en-US" sz="3400" dirty="0"/>
-          </a:p>
-        </p:txBody>
-      </p:sp>
-      <p:sp>
-        <p:nvSpPr>
-          <p:cNvPr id="6" name="Text 4"/>
-          <p:cNvSpPr txBox="1"/>
-          <p:nvPr/>
-        </p:nvSpPr>
-        <p:spPr>
-          <a:xfrm>
-            <a:off x="822960" y="4434840"/>
-            <a:ext cx="9326880" cy="822960"/>
-          </a:xfrm>
-          <a:prstGeom prst="rect">
-            <a:avLst/>
-          </a:prstGeom>
-          <a:noFill/>
-          <a:ln/>
-        </p:spPr>
-        <p:txBody>
-          <a:bodyPr wrap="square" lIns="0" tIns="0" rIns="0" bIns="0" rtlCol="0" anchor="ctr"/>
+              <a:t>2</a:t>
+            </a:r>
+            <a:endParaRPr lang="en-US" sz="2000" dirty="0"/>
+          </a:p>
+        </p:txBody>
+      </p:sp>
+      <p:sp>
+        <p:nvSpPr>
+          <p:cNvPr id="12" name="Text 10"/>
+          <p:cNvSpPr txBox="1"/>
+          <p:nvPr/>
+        </p:nvSpPr>
+        <p:spPr>
+          <a:xfrm>
+            <a:off x="7040880" y="2075688"/>
+            <a:ext cx="3840480" cy="731520"/>
+          </a:xfrm>
+          <a:prstGeom prst="rect">
+            <a:avLst/>
+          </a:prstGeom>
+          <a:noFill/>
+          <a:ln/>
+        </p:spPr>
+        <p:txBody>
+          <a:bodyPr wrap="square" lIns="0" tIns="0" rIns="0" bIns="0" rtlCol="0" anchor="t"/>
           <a:lstStyle/>
           <a:p>
             <a:pPr indent="0" marL="0">
               <a:lnSpc>
-                <a:spcPts val="2200"/>
+                <a:spcPts val="1700"/>
               </a:lnSpc>
               <a:buNone/>
             </a:pPr>
             <a:r>
-              <a:rPr lang="en-US" sz="1600" i="1" dirty="0">
+              <a:rPr lang="en-US" sz="1450" b="1" dirty="0">
+                <a:solidFill>
+                  <a:srgbClr val="FFFFFF"/>
+                </a:solidFill>
+                <a:latin typeface="Cambria" pitchFamily="34" charset="0"/>
+                <a:ea typeface="Cambria" pitchFamily="34" charset="-122"/>
+                <a:cs typeface="Cambria" pitchFamily="34" charset="-120"/>
+              </a:rPr>
+              <a:t>New-service funding, named destinations</a:t>
+            </a:r>
+            <a:endParaRPr lang="en-US" sz="1450" dirty="0"/>
+          </a:p>
+        </p:txBody>
+      </p:sp>
+      <p:sp>
+        <p:nvSpPr>
+          <p:cNvPr id="13" name="Text 11"/>
+          <p:cNvSpPr txBox="1"/>
+          <p:nvPr/>
+        </p:nvSpPr>
+        <p:spPr>
+          <a:xfrm>
+            <a:off x="6355080" y="2898648"/>
+            <a:ext cx="4526280" cy="758952"/>
+          </a:xfrm>
+          <a:prstGeom prst="rect">
+            <a:avLst/>
+          </a:prstGeom>
+          <a:noFill/>
+          <a:ln/>
+        </p:spPr>
+        <p:txBody>
+          <a:bodyPr wrap="square" lIns="0" tIns="0" rIns="0" bIns="0" rtlCol="0" anchor="t"/>
+          <a:lstStyle/>
+          <a:p>
+            <a:pPr indent="0" marL="0">
+              <a:lnSpc>
+                <a:spcPts val="1500"/>
+              </a:lnSpc>
+              <a:buNone/>
+            </a:pPr>
+            <a:r>
+              <a:rPr lang="en-US" sz="1200" dirty="0">
                 <a:solidFill>
                   <a:srgbClr val="CADCFC"/>
                 </a:solidFill>
@@ -5944,22 +5664,64 @@
                 <a:ea typeface="Calibri" pitchFamily="34" charset="-122"/>
                 <a:cs typeface="Calibri" pitchFamily="34" charset="-120"/>
               </a:rPr>
-              <a:t>All eight states and territories apply the same National Law.</a:t>
-            </a:r>
-            <a:endParaRPr lang="en-US" sz="1600" dirty="0"/>
-          </a:p>
-        </p:txBody>
-      </p:sp>
-      <p:sp>
-        <p:nvSpPr>
-          <p:cNvPr id="7" name="Text 5"/>
-          <p:cNvSpPr txBox="1"/>
-          <p:nvPr/>
-        </p:nvSpPr>
-        <p:spPr>
-          <a:xfrm>
-            <a:off x="11368735" y="6355080"/>
-            <a:ext cx="548640" cy="320040"/>
+              <a:t>WA's and the NT's Bounded Localities — 41km and 30km to a family's nearest backup option.</a:t>
+            </a:r>
+            <a:endParaRPr lang="en-US" sz="1200" dirty="0"/>
+          </a:p>
+        </p:txBody>
+      </p:sp>
+      <p:sp>
+        <p:nvSpPr>
+          <p:cNvPr id="14" name="Shape 12"/>
+          <p:cNvSpPr/>
+          <p:nvPr/>
+        </p:nvSpPr>
+        <p:spPr>
+          <a:xfrm>
+            <a:off x="640080" y="4114800"/>
+            <a:ext cx="5074920" cy="1965960"/>
+          </a:xfrm>
+          <a:prstGeom prst="roundRect">
+            <a:avLst>
+              <a:gd name="adj" fmla="val 4651"/>
+            </a:avLst>
+          </a:prstGeom>
+          <a:solidFill>
+            <a:srgbClr val="141B4D"/>
+          </a:solidFill>
+          <a:ln/>
+        </p:spPr>
+      </p:sp>
+      <p:sp>
+        <p:nvSpPr>
+          <p:cNvPr id="15" name="Shape 13"/>
+          <p:cNvSpPr/>
+          <p:nvPr/>
+        </p:nvSpPr>
+        <p:spPr>
+          <a:xfrm>
+            <a:off x="914400" y="4389120"/>
+            <a:ext cx="502920" cy="502920"/>
+          </a:xfrm>
+          <a:prstGeom prst="ellipse">
+            <a:avLst/>
+          </a:prstGeom>
+          <a:solidFill>
+            <a:srgbClr val="E34948"/>
+          </a:solidFill>
+          <a:ln/>
+        </p:spPr>
+      </p:sp>
+      <p:sp>
+        <p:nvSpPr>
+          <p:cNvPr id="16" name="Text 14"/>
+          <p:cNvSpPr txBox="1"/>
+          <p:nvPr/>
+        </p:nvSpPr>
+        <p:spPr>
+          <a:xfrm>
+            <a:off x="914400" y="4389120"/>
+            <a:ext cx="502920" cy="502920"/>
           </a:xfrm>
           <a:prstGeom prst="rect">
             <a:avLst/>
@@ -5971,19 +5733,346 @@
           <a:bodyPr wrap="square" lIns="0" tIns="0" rIns="0" bIns="0" rtlCol="0" anchor="ctr"/>
           <a:lstStyle/>
           <a:p>
-            <a:pPr algn="r" indent="0" marL="0">
-              <a:buNone/>
-            </a:pPr>
-            <a:r>
-              <a:rPr lang="en-US" sz="1000" dirty="0">
-                <a:solidFill>
-                  <a:srgbClr val="5B6472"/>
+            <a:pPr algn="ctr" indent="0" marL="0">
+              <a:buNone/>
+            </a:pPr>
+            <a:r>
+              <a:rPr lang="en-US" sz="2000" b="1" dirty="0">
+                <a:solidFill>
+                  <a:srgbClr val="FFFFFF"/>
+                </a:solidFill>
+                <a:latin typeface="Cambria" pitchFamily="34" charset="0"/>
+                <a:ea typeface="Cambria" pitchFamily="34" charset="-122"/>
+                <a:cs typeface="Cambria" pitchFamily="34" charset="-120"/>
+              </a:rPr>
+              <a:t>3</a:t>
+            </a:r>
+            <a:endParaRPr lang="en-US" sz="2000" dirty="0"/>
+          </a:p>
+        </p:txBody>
+      </p:sp>
+      <p:sp>
+        <p:nvSpPr>
+          <p:cNvPr id="17" name="Text 15"/>
+          <p:cNvSpPr txBox="1"/>
+          <p:nvPr/>
+        </p:nvSpPr>
+        <p:spPr>
+          <a:xfrm>
+            <a:off x="1600200" y="4315968"/>
+            <a:ext cx="3840480" cy="731520"/>
+          </a:xfrm>
+          <a:prstGeom prst="rect">
+            <a:avLst/>
+          </a:prstGeom>
+          <a:noFill/>
+          <a:ln/>
+        </p:spPr>
+        <p:txBody>
+          <a:bodyPr wrap="square" lIns="0" tIns="0" rIns="0" bIns="0" rtlCol="0" anchor="t"/>
+          <a:lstStyle/>
+          <a:p>
+            <a:pPr indent="0" marL="0">
+              <a:lnSpc>
+                <a:spcPts val="1700"/>
+              </a:lnSpc>
+              <a:buNone/>
+            </a:pPr>
+            <a:r>
+              <a:rPr lang="en-US" sz="1450" b="1" dirty="0">
+                <a:solidFill>
+                  <a:srgbClr val="FFFFFF"/>
+                </a:solidFill>
+                <a:latin typeface="Cambria" pitchFamily="34" charset="0"/>
+                <a:ea typeface="Cambria" pitchFamily="34" charset="-122"/>
+                <a:cs typeface="Cambria" pitchFamily="34" charset="-120"/>
+              </a:rPr>
+              <a:t>Transport as a rural equity investment</a:t>
+            </a:r>
+            <a:endParaRPr lang="en-US" sz="1450" dirty="0"/>
+          </a:p>
+        </p:txBody>
+      </p:sp>
+      <p:sp>
+        <p:nvSpPr>
+          <p:cNvPr id="18" name="Text 16"/>
+          <p:cNvSpPr txBox="1"/>
+          <p:nvPr/>
+        </p:nvSpPr>
+        <p:spPr>
+          <a:xfrm>
+            <a:off x="914400" y="5138928"/>
+            <a:ext cx="4526280" cy="758952"/>
+          </a:xfrm>
+          <a:prstGeom prst="rect">
+            <a:avLst/>
+          </a:prstGeom>
+          <a:noFill/>
+          <a:ln/>
+        </p:spPr>
+        <p:txBody>
+          <a:bodyPr wrap="square" lIns="0" tIns="0" rIns="0" bIns="0" rtlCol="0" anchor="t"/>
+          <a:lstStyle/>
+          <a:p>
+            <a:pPr indent="0" marL="0">
+              <a:lnSpc>
+                <a:spcPts val="1500"/>
+              </a:lnSpc>
+              <a:buNone/>
+            </a:pPr>
+            <a:r>
+              <a:rPr lang="en-US" sz="1200" dirty="0">
+                <a:solidFill>
+                  <a:srgbClr val="CADCFC"/>
                 </a:solidFill>
                 <a:latin typeface="Calibri" pitchFamily="34" charset="0"/>
                 <a:ea typeface="Calibri" pitchFamily="34" charset="-122"/>
                 <a:cs typeface="Calibri" pitchFamily="34" charset="-120"/>
               </a:rPr>
-              <a:t>03</a:t>
+              <a:t>Real but small as a quality lever — fund it for equity, not as a compliance play.</a:t>
+            </a:r>
+            <a:endParaRPr lang="en-US" sz="1200" dirty="0"/>
+          </a:p>
+        </p:txBody>
+      </p:sp>
+      <p:sp>
+        <p:nvSpPr>
+          <p:cNvPr id="19" name="Shape 17"/>
+          <p:cNvSpPr/>
+          <p:nvPr/>
+        </p:nvSpPr>
+        <p:spPr>
+          <a:xfrm>
+            <a:off x="6080760" y="4114800"/>
+            <a:ext cx="5074920" cy="1965960"/>
+          </a:xfrm>
+          <a:prstGeom prst="roundRect">
+            <a:avLst>
+              <a:gd name="adj" fmla="val 4651"/>
+            </a:avLst>
+          </a:prstGeom>
+          <a:solidFill>
+            <a:srgbClr val="141B4D"/>
+          </a:solidFill>
+          <a:ln/>
+        </p:spPr>
+      </p:sp>
+      <p:sp>
+        <p:nvSpPr>
+          <p:cNvPr id="20" name="Shape 18"/>
+          <p:cNvSpPr/>
+          <p:nvPr/>
+        </p:nvSpPr>
+        <p:spPr>
+          <a:xfrm>
+            <a:off x="6355080" y="4389120"/>
+            <a:ext cx="502920" cy="502920"/>
+          </a:xfrm>
+          <a:prstGeom prst="ellipse">
+            <a:avLst/>
+          </a:prstGeom>
+          <a:solidFill>
+            <a:srgbClr val="E34948"/>
+          </a:solidFill>
+          <a:ln/>
+        </p:spPr>
+      </p:sp>
+      <p:sp>
+        <p:nvSpPr>
+          <p:cNvPr id="21" name="Text 19"/>
+          <p:cNvSpPr txBox="1"/>
+          <p:nvPr/>
+        </p:nvSpPr>
+        <p:spPr>
+          <a:xfrm>
+            <a:off x="6355080" y="4389120"/>
+            <a:ext cx="502920" cy="502920"/>
+          </a:xfrm>
+          <a:prstGeom prst="rect">
+            <a:avLst/>
+          </a:prstGeom>
+          <a:noFill/>
+          <a:ln/>
+        </p:spPr>
+        <p:txBody>
+          <a:bodyPr wrap="square" lIns="0" tIns="0" rIns="0" bIns="0" rtlCol="0" anchor="ctr"/>
+          <a:lstStyle/>
+          <a:p>
+            <a:pPr algn="ctr" indent="0" marL="0">
+              <a:buNone/>
+            </a:pPr>
+            <a:r>
+              <a:rPr lang="en-US" sz="2000" b="1" dirty="0">
+                <a:solidFill>
+                  <a:srgbClr val="FFFFFF"/>
+                </a:solidFill>
+                <a:latin typeface="Cambria" pitchFamily="34" charset="0"/>
+                <a:ea typeface="Cambria" pitchFamily="34" charset="-122"/>
+                <a:cs typeface="Cambria" pitchFamily="34" charset="-120"/>
+              </a:rPr>
+              <a:t>4</a:t>
+            </a:r>
+            <a:endParaRPr lang="en-US" sz="2000" dirty="0"/>
+          </a:p>
+        </p:txBody>
+      </p:sp>
+      <p:sp>
+        <p:nvSpPr>
+          <p:cNvPr id="22" name="Text 20"/>
+          <p:cNvSpPr txBox="1"/>
+          <p:nvPr/>
+        </p:nvSpPr>
+        <p:spPr>
+          <a:xfrm>
+            <a:off x="7040880" y="4315968"/>
+            <a:ext cx="3840480" cy="731520"/>
+          </a:xfrm>
+          <a:prstGeom prst="rect">
+            <a:avLst/>
+          </a:prstGeom>
+          <a:noFill/>
+          <a:ln/>
+        </p:spPr>
+        <p:txBody>
+          <a:bodyPr wrap="square" lIns="0" tIns="0" rIns="0" bIns="0" rtlCol="0" anchor="t"/>
+          <a:lstStyle/>
+          <a:p>
+            <a:pPr indent="0" marL="0">
+              <a:lnSpc>
+                <a:spcPts val="1700"/>
+              </a:lnSpc>
+              <a:buNone/>
+            </a:pPr>
+            <a:r>
+              <a:rPr lang="en-US" sz="1450" b="1" dirty="0">
+                <a:solidFill>
+                  <a:srgbClr val="FFFFFF"/>
+                </a:solidFill>
+                <a:latin typeface="Cambria" pitchFamily="34" charset="0"/>
+                <a:ea typeface="Cambria" pitchFamily="34" charset="-122"/>
+                <a:cs typeface="Cambria" pitchFamily="34" charset="-120"/>
+              </a:rPr>
+              <a:t>A support pathway for newly-approved services</a:t>
+            </a:r>
+            <a:endParaRPr lang="en-US" sz="1450" dirty="0"/>
+          </a:p>
+        </p:txBody>
+      </p:sp>
+      <p:sp>
+        <p:nvSpPr>
+          <p:cNvPr id="23" name="Text 21"/>
+          <p:cNvSpPr txBox="1"/>
+          <p:nvPr/>
+        </p:nvSpPr>
+        <p:spPr>
+          <a:xfrm>
+            <a:off x="6355080" y="5138928"/>
+            <a:ext cx="4526280" cy="758952"/>
+          </a:xfrm>
+          <a:prstGeom prst="rect">
+            <a:avLst/>
+          </a:prstGeom>
+          <a:noFill/>
+          <a:ln/>
+        </p:spPr>
+        <p:txBody>
+          <a:bodyPr wrap="square" lIns="0" tIns="0" rIns="0" bIns="0" rtlCol="0" anchor="t"/>
+          <a:lstStyle/>
+          <a:p>
+            <a:pPr indent="0" marL="0">
+              <a:lnSpc>
+                <a:spcPts val="1500"/>
+              </a:lnSpc>
+              <a:buNone/>
+            </a:pPr>
+            <a:r>
+              <a:rPr lang="en-US" sz="1200" dirty="0">
+                <a:solidFill>
+                  <a:srgbClr val="CADCFC"/>
+                </a:solidFill>
+                <a:latin typeface="Calibri" pitchFamily="34" charset="0"/>
+                <a:ea typeface="Calibri" pitchFamily="34" charset="-122"/>
+                <a:cs typeface="Calibri" pitchFamily="34" charset="-120"/>
+              </a:rPr>
+              <a:t>Not a compliance one — they just haven't had the years yet.</a:t>
+            </a:r>
+            <a:endParaRPr lang="en-US" sz="1200" dirty="0"/>
+          </a:p>
+        </p:txBody>
+      </p:sp>
+      <p:sp>
+        <p:nvSpPr>
+          <p:cNvPr id="24" name="Text 22"/>
+          <p:cNvSpPr txBox="1"/>
+          <p:nvPr/>
+        </p:nvSpPr>
+        <p:spPr>
+          <a:xfrm>
+            <a:off x="640080" y="6172200"/>
+            <a:ext cx="7315200" cy="365760"/>
+          </a:xfrm>
+          <a:prstGeom prst="rect">
+            <a:avLst/>
+          </a:prstGeom>
+          <a:noFill/>
+          <a:ln/>
+        </p:spPr>
+        <p:txBody>
+          <a:bodyPr wrap="square" lIns="0" tIns="0" rIns="0" bIns="0" rtlCol="0" anchor="ctr"/>
+          <a:lstStyle/>
+          <a:p>
+            <a:pPr indent="0" marL="0">
+              <a:buNone/>
+            </a:pPr>
+            <a:r>
+              <a:rPr lang="en-US" sz="1400" i="1" dirty="0">
+                <a:solidFill>
+                  <a:srgbClr val="CADCFC"/>
+                </a:solidFill>
+                <a:latin typeface="Calibri" pitchFamily="34" charset="0"/>
+                <a:ea typeface="Calibri" pitchFamily="34" charset="-122"/>
+                <a:cs typeface="Calibri" pitchFamily="34" charset="-120"/>
+              </a:rPr>
+              <a:t>A budget with a reason behind every line.</a:t>
+            </a:r>
+            <a:endParaRPr lang="en-US" sz="1400" dirty="0"/>
+          </a:p>
+        </p:txBody>
+      </p:sp>
+      <p:sp>
+        <p:nvSpPr>
+          <p:cNvPr id="25" name="Text 23"/>
+          <p:cNvSpPr txBox="1"/>
+          <p:nvPr/>
+        </p:nvSpPr>
+        <p:spPr>
+          <a:xfrm>
+            <a:off x="11368735" y="6355080"/>
+            <a:ext cx="548640" cy="320040"/>
+          </a:xfrm>
+          <a:prstGeom prst="rect">
+            <a:avLst/>
+          </a:prstGeom>
+          <a:noFill/>
+          <a:ln/>
+        </p:spPr>
+        <p:txBody>
+          <a:bodyPr wrap="square" lIns="0" tIns="0" rIns="0" bIns="0" rtlCol="0" anchor="ctr"/>
+          <a:lstStyle/>
+          <a:p>
+            <a:pPr algn="r" indent="0" marL="0">
+              <a:buNone/>
+            </a:pPr>
+            <a:r>
+              <a:rPr lang="en-US" sz="1000" dirty="0">
+                <a:solidFill>
+                  <a:srgbClr val="5B6472"/>
+                </a:solidFill>
+                <a:latin typeface="Calibri" pitchFamily="34" charset="0"/>
+                <a:ea typeface="Calibri" pitchFamily="34" charset="-122"/>
+                <a:cs typeface="Calibri" pitchFamily="34" charset="-120"/>
+              </a:rPr>
+              <a:t>20</a:t>
             </a:r>
             <a:endParaRPr lang="en-US" sz="1000" dirty="0"/>
           </a:p>
@@ -5997,9 +6086,9 @@
 </p:sld>
 </file>
 
-<file path=ppt/slides/slide4.xml><?xml version="1.0" encoding="utf-8"?>
+<file path=ppt/slides/slide3.xml><?xml version="1.0" encoding="utf-8"?>
 <p:sld xmlns:a="http://schemas.openxmlformats.org/drawingml/2006/main" xmlns:r="http://schemas.openxmlformats.org/officeDocument/2006/relationships" xmlns:p="http://schemas.openxmlformats.org/presentationml/2006/main">
-  <p:cSld name="Slide 4">
+  <p:cSld name="Slide 3">
     <p:bg>
       <p:bgPr>
         <a:solidFill>
@@ -6054,7 +6143,7 @@
                 <a:ea typeface="Calibri" pitchFamily="34" charset="-122"/>
                 <a:cs typeface="Calibri" pitchFamily="34" charset="-120"/>
               </a:rPr>
-              <a:t>PROBLEM 1 · CHART 1</a:t>
+              <a:t>LIMITATIONS</a:t>
             </a:r>
             <a:endParaRPr lang="en-US" sz="1300" dirty="0"/>
           </a:p>
@@ -6068,27 +6157,24 @@
         </p:nvSpPr>
         <p:spPr>
           <a:xfrm>
-            <a:off x="640080" y="731520"/>
-            <a:ext cx="10911535" cy="960120"/>
-          </a:xfrm>
-          <a:prstGeom prst="rect">
-            <a:avLst/>
-          </a:prstGeom>
-          <a:noFill/>
-          <a:ln/>
-        </p:spPr>
-        <p:txBody>
-          <a:bodyPr wrap="square" lIns="0" tIns="0" rIns="0" bIns="0" rtlCol="0" anchor="t"/>
+            <a:off x="640080" y="749808"/>
+            <a:ext cx="10911535" cy="822960"/>
+          </a:xfrm>
+          <a:prstGeom prst="rect">
+            <a:avLst/>
+          </a:prstGeom>
+          <a:noFill/>
+          <a:ln/>
+        </p:spPr>
+        <p:txBody>
+          <a:bodyPr wrap="square" lIns="0" tIns="0" rIns="0" bIns="0" rtlCol="0" anchor="ctr"/>
           <a:lstStyle/>
           <a:p>
             <a:pPr indent="0" marL="0">
-              <a:lnSpc>
-                <a:spcPts val="2800"/>
-              </a:lnSpc>
-              <a:buNone/>
-            </a:pPr>
-            <a:r>
-              <a:rPr lang="en-US" sz="2400" b="1" dirty="0">
+              <a:buNone/>
+            </a:pPr>
+            <a:r>
+              <a:rPr lang="en-US" sz="3000" b="1" dirty="0">
                 <a:solidFill>
                   <a:srgbClr val="1E2761"/>
                 </a:solidFill>
@@ -6096,46 +6182,968 @@
                 <a:ea typeface="Cambria" pitchFamily="34" charset="-122"/>
                 <a:cs typeface="Cambria" pitchFamily="34" charset="-120"/>
               </a:rPr>
-              <a:t>Same law, a 5x compliance gap between states</a:t>
-            </a:r>
-            <a:endParaRPr lang="en-US" sz="2400" dirty="0"/>
-          </a:p>
-        </p:txBody>
-      </p:sp>
-      <p:pic>
-        <p:nvPicPr>
-          <p:cNvPr id="4" name="Image 0" descr="/home/user/Mart/outputs/figures/01_rating_by_state.png">    </p:cNvPr>
-          <p:cNvPicPr>
-            <a:picLocks noChangeAspect="1"/>
-          </p:cNvPicPr>
-          <p:nvPr/>
-        </p:nvPicPr>
-        <p:blipFill>
-          <a:blip r:embed="rId1"/>
-          <a:stretch>
-            <a:fillRect/>
-          </a:stretch>
-        </p:blipFill>
-        <p:spPr>
-          <a:xfrm>
-            <a:off x="2337136" y="1783080"/>
-            <a:ext cx="7517423" cy="4343400"/>
-          </a:xfrm>
-          <a:prstGeom prst="rect">
-            <a:avLst/>
-          </a:prstGeom>
-          <a:effectLst>
-            <a:outerShdw sx="100000" sy="100000" kx="0" ky="0" algn="bl" rotWithShape="0" blurRad="101600" dist="38100" dir="5400000">
-              <a:srgbClr val="0F1533">
-                <a:alpha val="35000"/>
-              </a:srgbClr>
-            </a:outerShdw>
-          </a:effectLst>
-        </p:spPr>
-      </p:pic>
-      <p:sp>
-        <p:nvSpPr>
-          <p:cNvPr id="5" name="Text 2"/>
+              <a:t>What this analysis can't tell you</a:t>
+            </a:r>
+            <a:endParaRPr lang="en-US" sz="3000" dirty="0"/>
+          </a:p>
+        </p:txBody>
+      </p:sp>
+      <p:sp>
+        <p:nvSpPr>
+          <p:cNvPr id="4" name="Shape 2"/>
+          <p:cNvSpPr/>
+          <p:nvPr/>
+        </p:nvSpPr>
+        <p:spPr>
+          <a:xfrm>
+            <a:off x="640080" y="1783080"/>
+            <a:ext cx="10911535" cy="731520"/>
+          </a:xfrm>
+          <a:prstGeom prst="roundRect">
+            <a:avLst>
+              <a:gd name="adj" fmla="val 10000"/>
+            </a:avLst>
+          </a:prstGeom>
+          <a:solidFill>
+            <a:srgbClr val="F4F6FB"/>
+          </a:solidFill>
+          <a:ln/>
+        </p:spPr>
+      </p:sp>
+      <p:sp>
+        <p:nvSpPr>
+          <p:cNvPr id="5" name="Shape 3"/>
+          <p:cNvSpPr/>
+          <p:nvPr/>
+        </p:nvSpPr>
+        <p:spPr>
+          <a:xfrm>
+            <a:off x="868680" y="1956816"/>
+            <a:ext cx="384048" cy="384048"/>
+          </a:xfrm>
+          <a:prstGeom prst="ellipse">
+            <a:avLst/>
+          </a:prstGeom>
+          <a:solidFill>
+            <a:srgbClr val="E34948"/>
+          </a:solidFill>
+          <a:ln/>
+        </p:spPr>
+      </p:sp>
+      <p:sp>
+        <p:nvSpPr>
+          <p:cNvPr id="6" name="Text 4"/>
+          <p:cNvSpPr txBox="1"/>
+          <p:nvPr/>
+        </p:nvSpPr>
+        <p:spPr>
+          <a:xfrm>
+            <a:off x="868680" y="1956816"/>
+            <a:ext cx="384048" cy="384048"/>
+          </a:xfrm>
+          <a:prstGeom prst="rect">
+            <a:avLst/>
+          </a:prstGeom>
+          <a:noFill/>
+          <a:ln/>
+        </p:spPr>
+        <p:txBody>
+          <a:bodyPr wrap="square" lIns="0" tIns="0" rIns="0" bIns="0" rtlCol="0" anchor="ctr"/>
+          <a:lstStyle/>
+          <a:p>
+            <a:pPr algn="ctr" indent="0" marL="0">
+              <a:buNone/>
+            </a:pPr>
+            <a:r>
+              <a:rPr lang="en-US" sz="1500" b="1" dirty="0">
+                <a:solidFill>
+                  <a:srgbClr val="FFFFFF"/>
+                </a:solidFill>
+                <a:latin typeface="Cambria" pitchFamily="34" charset="0"/>
+                <a:ea typeface="Cambria" pitchFamily="34" charset="-122"/>
+                <a:cs typeface="Cambria" pitchFamily="34" charset="-120"/>
+              </a:rPr>
+              <a:t>1</a:t>
+            </a:r>
+            <a:endParaRPr lang="en-US" sz="1500" dirty="0"/>
+          </a:p>
+        </p:txBody>
+      </p:sp>
+      <p:sp>
+        <p:nvSpPr>
+          <p:cNvPr id="7" name="Text 5"/>
+          <p:cNvSpPr txBox="1"/>
+          <p:nvPr/>
+        </p:nvSpPr>
+        <p:spPr>
+          <a:xfrm>
+            <a:off x="1463040" y="1783080"/>
+            <a:ext cx="9814255" cy="731520"/>
+          </a:xfrm>
+          <a:prstGeom prst="rect">
+            <a:avLst/>
+          </a:prstGeom>
+          <a:noFill/>
+          <a:ln/>
+        </p:spPr>
+        <p:txBody>
+          <a:bodyPr wrap="square" lIns="0" tIns="0" rIns="0" bIns="0" rtlCol="0" anchor="ctr"/>
+          <a:lstStyle/>
+          <a:p>
+            <a:pPr indent="0" marL="0">
+              <a:lnSpc>
+                <a:spcPts val="1600"/>
+              </a:lnSpc>
+              <a:buNone/>
+            </a:pPr>
+            <a:r>
+              <a:rPr lang="en-US" sz="1350" b="1" dirty="0">
+                <a:solidFill>
+                  <a:srgbClr val="1E2761"/>
+                </a:solidFill>
+                <a:latin typeface="Cambria" pitchFamily="34" charset="0"/>
+                <a:ea typeface="Cambria" pitchFamily="34" charset="-122"/>
+                <a:cs typeface="Cambria" pitchFamily="34" charset="-120"/>
+              </a:rPr>
+              <a:t>A single snapshot, not a trend  </a:t>
+            </a:r>
+            <a:pPr indent="0" marL="0">
+              <a:lnSpc>
+                <a:spcPts val="1600"/>
+              </a:lnSpc>
+              <a:buNone/>
+            </a:pPr>
+            <a:r>
+              <a:rPr lang="en-US" sz="1250" dirty="0">
+                <a:solidFill>
+                  <a:srgbClr val="5B6472"/>
+                </a:solidFill>
+                <a:latin typeface="Calibri" pitchFamily="34" charset="0"/>
+                <a:ea typeface="Calibri" pitchFamily="34" charset="-122"/>
+                <a:cs typeface="Calibri" pitchFamily="34" charset="-120"/>
+              </a:rPr>
+              <a:t>The register captures one point in time. Claims about newer vs. established services compare different cohorts of services, not the same services tracked over years.</a:t>
+            </a:r>
+            <a:endParaRPr lang="en-US" sz="1350" dirty="0"/>
+          </a:p>
+        </p:txBody>
+      </p:sp>
+      <p:sp>
+        <p:nvSpPr>
+          <p:cNvPr id="8" name="Shape 6"/>
+          <p:cNvSpPr/>
+          <p:nvPr/>
+        </p:nvSpPr>
+        <p:spPr>
+          <a:xfrm>
+            <a:off x="640080" y="2633472"/>
+            <a:ext cx="10911535" cy="731520"/>
+          </a:xfrm>
+          <a:prstGeom prst="roundRect">
+            <a:avLst>
+              <a:gd name="adj" fmla="val 10000"/>
+            </a:avLst>
+          </a:prstGeom>
+          <a:solidFill>
+            <a:srgbClr val="F4F6FB"/>
+          </a:solidFill>
+          <a:ln/>
+        </p:spPr>
+      </p:sp>
+      <p:sp>
+        <p:nvSpPr>
+          <p:cNvPr id="9" name="Shape 7"/>
+          <p:cNvSpPr/>
+          <p:nvPr/>
+        </p:nvSpPr>
+        <p:spPr>
+          <a:xfrm>
+            <a:off x="868680" y="2807208"/>
+            <a:ext cx="384048" cy="384048"/>
+          </a:xfrm>
+          <a:prstGeom prst="ellipse">
+            <a:avLst/>
+          </a:prstGeom>
+          <a:solidFill>
+            <a:srgbClr val="E34948"/>
+          </a:solidFill>
+          <a:ln/>
+        </p:spPr>
+      </p:sp>
+      <p:sp>
+        <p:nvSpPr>
+          <p:cNvPr id="10" name="Text 8"/>
+          <p:cNvSpPr txBox="1"/>
+          <p:nvPr/>
+        </p:nvSpPr>
+        <p:spPr>
+          <a:xfrm>
+            <a:off x="868680" y="2807208"/>
+            <a:ext cx="384048" cy="384048"/>
+          </a:xfrm>
+          <a:prstGeom prst="rect">
+            <a:avLst/>
+          </a:prstGeom>
+          <a:noFill/>
+          <a:ln/>
+        </p:spPr>
+        <p:txBody>
+          <a:bodyPr wrap="square" lIns="0" tIns="0" rIns="0" bIns="0" rtlCol="0" anchor="ctr"/>
+          <a:lstStyle/>
+          <a:p>
+            <a:pPr algn="ctr" indent="0" marL="0">
+              <a:buNone/>
+            </a:pPr>
+            <a:r>
+              <a:rPr lang="en-US" sz="1500" b="1" dirty="0">
+                <a:solidFill>
+                  <a:srgbClr val="FFFFFF"/>
+                </a:solidFill>
+                <a:latin typeface="Cambria" pitchFamily="34" charset="0"/>
+                <a:ea typeface="Cambria" pitchFamily="34" charset="-122"/>
+                <a:cs typeface="Cambria" pitchFamily="34" charset="-120"/>
+              </a:rPr>
+              <a:t>2</a:t>
+            </a:r>
+            <a:endParaRPr lang="en-US" sz="1500" dirty="0"/>
+          </a:p>
+        </p:txBody>
+      </p:sp>
+      <p:sp>
+        <p:nvSpPr>
+          <p:cNvPr id="11" name="Text 9"/>
+          <p:cNvSpPr txBox="1"/>
+          <p:nvPr/>
+        </p:nvSpPr>
+        <p:spPr>
+          <a:xfrm>
+            <a:off x="1463040" y="2633472"/>
+            <a:ext cx="9814255" cy="731520"/>
+          </a:xfrm>
+          <a:prstGeom prst="rect">
+            <a:avLst/>
+          </a:prstGeom>
+          <a:noFill/>
+          <a:ln/>
+        </p:spPr>
+        <p:txBody>
+          <a:bodyPr wrap="square" lIns="0" tIns="0" rIns="0" bIns="0" rtlCol="0" anchor="ctr"/>
+          <a:lstStyle/>
+          <a:p>
+            <a:pPr indent="0" marL="0">
+              <a:lnSpc>
+                <a:spcPts val="1600"/>
+              </a:lnSpc>
+              <a:buNone/>
+            </a:pPr>
+            <a:r>
+              <a:rPr lang="en-US" sz="1350" b="1" dirty="0">
+                <a:solidFill>
+                  <a:srgbClr val="1E2761"/>
+                </a:solidFill>
+                <a:latin typeface="Cambria" pitchFamily="34" charset="0"/>
+                <a:ea typeface="Cambria" pitchFamily="34" charset="-122"/>
+                <a:cs typeface="Cambria" pitchFamily="34" charset="-120"/>
+              </a:rPr>
+              <a:t>Ratings are administrative, not independently audited  </a:t>
+            </a:r>
+            <a:pPr indent="0" marL="0">
+              <a:lnSpc>
+                <a:spcPts val="1600"/>
+              </a:lnSpc>
+              <a:buNone/>
+            </a:pPr>
+            <a:r>
+              <a:rPr lang="en-US" sz="1250" dirty="0">
+                <a:solidFill>
+                  <a:srgbClr val="5B6472"/>
+                </a:solidFill>
+                <a:latin typeface="Calibri" pitchFamily="34" charset="0"/>
+                <a:ea typeface="Calibri" pitchFamily="34" charset="-122"/>
+                <a:cs typeface="Calibri" pitchFamily="34" charset="-120"/>
+              </a:rPr>
+              <a:t>Quality ratings come from each state regulator's own assessment. Consistency of judgement across eight jurisdictions can't be verified from this data alone.</a:t>
+            </a:r>
+            <a:endParaRPr lang="en-US" sz="1350" dirty="0"/>
+          </a:p>
+        </p:txBody>
+      </p:sp>
+      <p:sp>
+        <p:nvSpPr>
+          <p:cNvPr id="12" name="Shape 10"/>
+          <p:cNvSpPr/>
+          <p:nvPr/>
+        </p:nvSpPr>
+        <p:spPr>
+          <a:xfrm>
+            <a:off x="640080" y="3483864"/>
+            <a:ext cx="10911535" cy="731520"/>
+          </a:xfrm>
+          <a:prstGeom prst="roundRect">
+            <a:avLst>
+              <a:gd name="adj" fmla="val 10000"/>
+            </a:avLst>
+          </a:prstGeom>
+          <a:solidFill>
+            <a:srgbClr val="F4F6FB"/>
+          </a:solidFill>
+          <a:ln/>
+        </p:spPr>
+      </p:sp>
+      <p:sp>
+        <p:nvSpPr>
+          <p:cNvPr id="13" name="Shape 11"/>
+          <p:cNvSpPr/>
+          <p:nvPr/>
+        </p:nvSpPr>
+        <p:spPr>
+          <a:xfrm>
+            <a:off x="868680" y="3657600"/>
+            <a:ext cx="384048" cy="384048"/>
+          </a:xfrm>
+          <a:prstGeom prst="ellipse">
+            <a:avLst/>
+          </a:prstGeom>
+          <a:solidFill>
+            <a:srgbClr val="E34948"/>
+          </a:solidFill>
+          <a:ln/>
+        </p:spPr>
+      </p:sp>
+      <p:sp>
+        <p:nvSpPr>
+          <p:cNvPr id="14" name="Text 12"/>
+          <p:cNvSpPr txBox="1"/>
+          <p:nvPr/>
+        </p:nvSpPr>
+        <p:spPr>
+          <a:xfrm>
+            <a:off x="868680" y="3657600"/>
+            <a:ext cx="384048" cy="384048"/>
+          </a:xfrm>
+          <a:prstGeom prst="rect">
+            <a:avLst/>
+          </a:prstGeom>
+          <a:noFill/>
+          <a:ln/>
+        </p:spPr>
+        <p:txBody>
+          <a:bodyPr wrap="square" lIns="0" tIns="0" rIns="0" bIns="0" rtlCol="0" anchor="ctr"/>
+          <a:lstStyle/>
+          <a:p>
+            <a:pPr algn="ctr" indent="0" marL="0">
+              <a:buNone/>
+            </a:pPr>
+            <a:r>
+              <a:rPr lang="en-US" sz="1500" b="1" dirty="0">
+                <a:solidFill>
+                  <a:srgbClr val="FFFFFF"/>
+                </a:solidFill>
+                <a:latin typeface="Cambria" pitchFamily="34" charset="0"/>
+                <a:ea typeface="Cambria" pitchFamily="34" charset="-122"/>
+                <a:cs typeface="Cambria" pitchFamily="34" charset="-120"/>
+              </a:rPr>
+              <a:t>3</a:t>
+            </a:r>
+            <a:endParaRPr lang="en-US" sz="1500" dirty="0"/>
+          </a:p>
+        </p:txBody>
+      </p:sp>
+      <p:sp>
+        <p:nvSpPr>
+          <p:cNvPr id="15" name="Text 13"/>
+          <p:cNvSpPr txBox="1"/>
+          <p:nvPr/>
+        </p:nvSpPr>
+        <p:spPr>
+          <a:xfrm>
+            <a:off x="1463040" y="3483864"/>
+            <a:ext cx="9814255" cy="731520"/>
+          </a:xfrm>
+          <a:prstGeom prst="rect">
+            <a:avLst/>
+          </a:prstGeom>
+          <a:noFill/>
+          <a:ln/>
+        </p:spPr>
+        <p:txBody>
+          <a:bodyPr wrap="square" lIns="0" tIns="0" rIns="0" bIns="0" rtlCol="0" anchor="ctr"/>
+          <a:lstStyle/>
+          <a:p>
+            <a:pPr indent="0" marL="0">
+              <a:lnSpc>
+                <a:spcPts val="1600"/>
+              </a:lnSpc>
+              <a:buNone/>
+            </a:pPr>
+            <a:r>
+              <a:rPr lang="en-US" sz="1350" b="1" dirty="0">
+                <a:solidFill>
+                  <a:srgbClr val="1E2761"/>
+                </a:solidFill>
+                <a:latin typeface="Cambria" pitchFamily="34" charset="0"/>
+                <a:ea typeface="Cambria" pitchFamily="34" charset="-122"/>
+                <a:cs typeface="Cambria" pitchFamily="34" charset="-120"/>
+              </a:rPr>
+              <a:t>Every relationship tested is correlational  </a:t>
+            </a:r>
+            <a:pPr indent="0" marL="0">
+              <a:lnSpc>
+                <a:spcPts val="1600"/>
+              </a:lnSpc>
+              <a:buNone/>
+            </a:pPr>
+            <a:r>
+              <a:rPr lang="en-US" sz="1250" dirty="0">
+                <a:solidFill>
+                  <a:srgbClr val="5B6472"/>
+                </a:solidFill>
+                <a:latin typeface="Calibri" pitchFamily="34" charset="0"/>
+                <a:ea typeface="Calibri" pitchFamily="34" charset="-122"/>
+                <a:cs typeface="Calibri" pitchFamily="34" charset="-120"/>
+              </a:rPr>
+              <a:t>Transport, hours, capacity and approval-cohort effects are observed associations, not proven causes. None of this establishes a causal mechanism.</a:t>
+            </a:r>
+            <a:endParaRPr lang="en-US" sz="1350" dirty="0"/>
+          </a:p>
+        </p:txBody>
+      </p:sp>
+      <p:sp>
+        <p:nvSpPr>
+          <p:cNvPr id="16" name="Shape 14"/>
+          <p:cNvSpPr/>
+          <p:nvPr/>
+        </p:nvSpPr>
+        <p:spPr>
+          <a:xfrm>
+            <a:off x="640080" y="4334256"/>
+            <a:ext cx="10911535" cy="731520"/>
+          </a:xfrm>
+          <a:prstGeom prst="roundRect">
+            <a:avLst>
+              <a:gd name="adj" fmla="val 10000"/>
+            </a:avLst>
+          </a:prstGeom>
+          <a:solidFill>
+            <a:srgbClr val="F4F6FB"/>
+          </a:solidFill>
+          <a:ln/>
+        </p:spPr>
+      </p:sp>
+      <p:sp>
+        <p:nvSpPr>
+          <p:cNvPr id="17" name="Shape 15"/>
+          <p:cNvSpPr/>
+          <p:nvPr/>
+        </p:nvSpPr>
+        <p:spPr>
+          <a:xfrm>
+            <a:off x="868680" y="4507992"/>
+            <a:ext cx="384048" cy="384048"/>
+          </a:xfrm>
+          <a:prstGeom prst="ellipse">
+            <a:avLst/>
+          </a:prstGeom>
+          <a:solidFill>
+            <a:srgbClr val="E34948"/>
+          </a:solidFill>
+          <a:ln/>
+        </p:spPr>
+      </p:sp>
+      <p:sp>
+        <p:nvSpPr>
+          <p:cNvPr id="18" name="Text 16"/>
+          <p:cNvSpPr txBox="1"/>
+          <p:nvPr/>
+        </p:nvSpPr>
+        <p:spPr>
+          <a:xfrm>
+            <a:off x="868680" y="4507992"/>
+            <a:ext cx="384048" cy="384048"/>
+          </a:xfrm>
+          <a:prstGeom prst="rect">
+            <a:avLst/>
+          </a:prstGeom>
+          <a:noFill/>
+          <a:ln/>
+        </p:spPr>
+        <p:txBody>
+          <a:bodyPr wrap="square" lIns="0" tIns="0" rIns="0" bIns="0" rtlCol="0" anchor="ctr"/>
+          <a:lstStyle/>
+          <a:p>
+            <a:pPr algn="ctr" indent="0" marL="0">
+              <a:buNone/>
+            </a:pPr>
+            <a:r>
+              <a:rPr lang="en-US" sz="1500" b="1" dirty="0">
+                <a:solidFill>
+                  <a:srgbClr val="FFFFFF"/>
+                </a:solidFill>
+                <a:latin typeface="Cambria" pitchFamily="34" charset="0"/>
+                <a:ea typeface="Cambria" pitchFamily="34" charset="-122"/>
+                <a:cs typeface="Cambria" pitchFamily="34" charset="-120"/>
+              </a:rPr>
+              <a:t>4</a:t>
+            </a:r>
+            <a:endParaRPr lang="en-US" sz="1500" dirty="0"/>
+          </a:p>
+        </p:txBody>
+      </p:sp>
+      <p:sp>
+        <p:nvSpPr>
+          <p:cNvPr id="19" name="Text 17"/>
+          <p:cNvSpPr txBox="1"/>
+          <p:nvPr/>
+        </p:nvSpPr>
+        <p:spPr>
+          <a:xfrm>
+            <a:off x="1463040" y="4334256"/>
+            <a:ext cx="9814255" cy="731520"/>
+          </a:xfrm>
+          <a:prstGeom prst="rect">
+            <a:avLst/>
+          </a:prstGeom>
+          <a:noFill/>
+          <a:ln/>
+        </p:spPr>
+        <p:txBody>
+          <a:bodyPr wrap="square" lIns="0" tIns="0" rIns="0" bIns="0" rtlCol="0" anchor="ctr"/>
+          <a:lstStyle/>
+          <a:p>
+            <a:pPr indent="0" marL="0">
+              <a:lnSpc>
+                <a:spcPts val="1600"/>
+              </a:lnSpc>
+              <a:buNone/>
+            </a:pPr>
+            <a:r>
+              <a:rPr lang="en-US" sz="1350" b="1" dirty="0">
+                <a:solidFill>
+                  <a:srgbClr val="1E2761"/>
+                </a:solidFill>
+                <a:latin typeface="Cambria" pitchFamily="34" charset="0"/>
+                <a:ea typeface="Cambria" pitchFamily="34" charset="-122"/>
+                <a:cs typeface="Cambria" pitchFamily="34" charset="-120"/>
+              </a:rPr>
+              <a:t>Some findings rest on small samples  </a:t>
+            </a:r>
+            <a:pPr indent="0" marL="0">
+              <a:lnSpc>
+                <a:spcPts val="1600"/>
+              </a:lnSpc>
+              <a:buNone/>
+            </a:pPr>
+            <a:r>
+              <a:rPr lang="en-US" sz="1250" dirty="0">
+                <a:solidFill>
+                  <a:srgbClr val="5B6472"/>
+                </a:solidFill>
+                <a:latin typeface="Calibri" pitchFamily="34" charset="0"/>
+                <a:ea typeface="Calibri" pitchFamily="34" charset="-122"/>
+                <a:cs typeface="Calibri" pitchFamily="34" charset="-120"/>
+              </a:rPr>
+              <a:t>The state-level rurality-vs-connectivity comparison has only eight data points, one per state — reported as illustrative, not statistically conclusive.</a:t>
+            </a:r>
+            <a:endParaRPr lang="en-US" sz="1350" dirty="0"/>
+          </a:p>
+        </p:txBody>
+      </p:sp>
+      <p:sp>
+        <p:nvSpPr>
+          <p:cNvPr id="20" name="Shape 18"/>
+          <p:cNvSpPr/>
+          <p:nvPr/>
+        </p:nvSpPr>
+        <p:spPr>
+          <a:xfrm>
+            <a:off x="640080" y="5184648"/>
+            <a:ext cx="10911535" cy="731520"/>
+          </a:xfrm>
+          <a:prstGeom prst="roundRect">
+            <a:avLst>
+              <a:gd name="adj" fmla="val 10000"/>
+            </a:avLst>
+          </a:prstGeom>
+          <a:solidFill>
+            <a:srgbClr val="F4F6FB"/>
+          </a:solidFill>
+          <a:ln/>
+        </p:spPr>
+      </p:sp>
+      <p:sp>
+        <p:nvSpPr>
+          <p:cNvPr id="21" name="Shape 19"/>
+          <p:cNvSpPr/>
+          <p:nvPr/>
+        </p:nvSpPr>
+        <p:spPr>
+          <a:xfrm>
+            <a:off x="868680" y="5358384"/>
+            <a:ext cx="384048" cy="384048"/>
+          </a:xfrm>
+          <a:prstGeom prst="ellipse">
+            <a:avLst/>
+          </a:prstGeom>
+          <a:solidFill>
+            <a:srgbClr val="E34948"/>
+          </a:solidFill>
+          <a:ln/>
+        </p:spPr>
+      </p:sp>
+      <p:sp>
+        <p:nvSpPr>
+          <p:cNvPr id="22" name="Text 20"/>
+          <p:cNvSpPr txBox="1"/>
+          <p:nvPr/>
+        </p:nvSpPr>
+        <p:spPr>
+          <a:xfrm>
+            <a:off x="868680" y="5358384"/>
+            <a:ext cx="384048" cy="384048"/>
+          </a:xfrm>
+          <a:prstGeom prst="rect">
+            <a:avLst/>
+          </a:prstGeom>
+          <a:noFill/>
+          <a:ln/>
+        </p:spPr>
+        <p:txBody>
+          <a:bodyPr wrap="square" lIns="0" tIns="0" rIns="0" bIns="0" rtlCol="0" anchor="ctr"/>
+          <a:lstStyle/>
+          <a:p>
+            <a:pPr algn="ctr" indent="0" marL="0">
+              <a:buNone/>
+            </a:pPr>
+            <a:r>
+              <a:rPr lang="en-US" sz="1500" b="1" dirty="0">
+                <a:solidFill>
+                  <a:srgbClr val="FFFFFF"/>
+                </a:solidFill>
+                <a:latin typeface="Cambria" pitchFamily="34" charset="0"/>
+                <a:ea typeface="Cambria" pitchFamily="34" charset="-122"/>
+                <a:cs typeface="Cambria" pitchFamily="34" charset="-120"/>
+              </a:rPr>
+              <a:t>5</a:t>
+            </a:r>
+            <a:endParaRPr lang="en-US" sz="1500" dirty="0"/>
+          </a:p>
+        </p:txBody>
+      </p:sp>
+      <p:sp>
+        <p:nvSpPr>
+          <p:cNvPr id="23" name="Text 21"/>
+          <p:cNvSpPr txBox="1"/>
+          <p:nvPr/>
+        </p:nvSpPr>
+        <p:spPr>
+          <a:xfrm>
+            <a:off x="1463040" y="5184648"/>
+            <a:ext cx="9814255" cy="731520"/>
+          </a:xfrm>
+          <a:prstGeom prst="rect">
+            <a:avLst/>
+          </a:prstGeom>
+          <a:noFill/>
+          <a:ln/>
+        </p:spPr>
+        <p:txBody>
+          <a:bodyPr wrap="square" lIns="0" tIns="0" rIns="0" bIns="0" rtlCol="0" anchor="ctr"/>
+          <a:lstStyle/>
+          <a:p>
+            <a:pPr indent="0" marL="0">
+              <a:lnSpc>
+                <a:spcPts val="1600"/>
+              </a:lnSpc>
+              <a:buNone/>
+            </a:pPr>
+            <a:r>
+              <a:rPr lang="en-US" sz="1350" b="1" dirty="0">
+                <a:solidFill>
+                  <a:srgbClr val="1E2761"/>
+                </a:solidFill>
+                <a:latin typeface="Cambria" pitchFamily="34" charset="0"/>
+                <a:ea typeface="Cambria" pitchFamily="34" charset="-122"/>
+                <a:cs typeface="Cambria" pitchFamily="34" charset="-120"/>
+              </a:rPr>
+              <a:t>Key definitions are modelling choices  </a:t>
+            </a:r>
+            <a:pPr indent="0" marL="0">
+              <a:lnSpc>
+                <a:spcPts val="1600"/>
+              </a:lnSpc>
+              <a:buNone/>
+            </a:pPr>
+            <a:r>
+              <a:rPr lang="en-US" sz="1250" dirty="0">
+                <a:solidFill>
+                  <a:srgbClr val="5B6472"/>
+                </a:solidFill>
+                <a:latin typeface="Calibri" pitchFamily="34" charset="0"/>
+                <a:ea typeface="Calibri" pitchFamily="34" charset="-122"/>
+                <a:cs typeface="Calibri" pitchFamily="34" charset="-120"/>
+              </a:rPr>
+              <a:t>“Well-connected” (5km/10km) and “non-compliance” thresholds are reasonable, stated choices. Different cutoffs would shift specific percentages, though not the overall pattern.</a:t>
+            </a:r>
+            <a:endParaRPr lang="en-US" sz="1350" dirty="0"/>
+          </a:p>
+        </p:txBody>
+      </p:sp>
+      <p:sp>
+        <p:nvSpPr>
+          <p:cNvPr id="24" name="Text 22"/>
+          <p:cNvSpPr txBox="1"/>
+          <p:nvPr/>
+        </p:nvSpPr>
+        <p:spPr>
+          <a:xfrm>
+            <a:off x="11368735" y="6355080"/>
+            <a:ext cx="548640" cy="320040"/>
+          </a:xfrm>
+          <a:prstGeom prst="rect">
+            <a:avLst/>
+          </a:prstGeom>
+          <a:noFill/>
+          <a:ln/>
+        </p:spPr>
+        <p:txBody>
+          <a:bodyPr wrap="square" lIns="0" tIns="0" rIns="0" bIns="0" rtlCol="0" anchor="ctr"/>
+          <a:lstStyle/>
+          <a:p>
+            <a:pPr algn="r" indent="0" marL="0">
+              <a:buNone/>
+            </a:pPr>
+            <a:r>
+              <a:rPr lang="en-US" sz="1000" dirty="0">
+                <a:solidFill>
+                  <a:srgbClr val="5B6472"/>
+                </a:solidFill>
+                <a:latin typeface="Calibri" pitchFamily="34" charset="0"/>
+                <a:ea typeface="Calibri" pitchFamily="34" charset="-122"/>
+                <a:cs typeface="Calibri" pitchFamily="34" charset="-120"/>
+              </a:rPr>
+              <a:t>03</a:t>
+            </a:r>
+            <a:endParaRPr lang="en-US" sz="1000" dirty="0"/>
+          </a:p>
+        </p:txBody>
+      </p:sp>
+    </p:spTree>
+  </p:cSld>
+  <p:clrMapOvr>
+    <a:masterClrMapping/>
+  </p:clrMapOvr>
+</p:sld>
+</file>
+
+<file path=ppt/slides/slide4.xml><?xml version="1.0" encoding="utf-8"?>
+<p:sld xmlns:a="http://schemas.openxmlformats.org/drawingml/2006/main" xmlns:r="http://schemas.openxmlformats.org/officeDocument/2006/relationships" xmlns:p="http://schemas.openxmlformats.org/presentationml/2006/main">
+  <p:cSld name="Slide 4">
+    <p:bg>
+      <p:bgPr>
+        <a:solidFill>
+          <a:srgbClr val="1E2761"/>
+        </a:solidFill>
+      </p:bgPr>
+    </p:bg>
+    <p:spTree>
+      <p:nvGrpSpPr>
+        <p:cNvPr id="1" name=""/>
+        <p:cNvGrpSpPr/>
+        <p:nvPr/>
+      </p:nvGrpSpPr>
+      <p:grpSpPr>
+        <a:xfrm>
+          <a:off x="0" y="0"/>
+          <a:ext cx="0" cy="0"/>
+          <a:chOff x="0" y="0"/>
+          <a:chExt cx="0" cy="0"/>
+        </a:xfrm>
+      </p:grpSpPr>
+      <p:sp>
+        <p:nvSpPr>
+          <p:cNvPr id="2" name="Shape 0"/>
+          <p:cNvSpPr/>
+          <p:nvPr/>
+        </p:nvSpPr>
+        <p:spPr>
+          <a:xfrm>
+            <a:off x="822960" y="777240"/>
+            <a:ext cx="1051560" cy="1051560"/>
+          </a:xfrm>
+          <a:prstGeom prst="ellipse">
+            <a:avLst/>
+          </a:prstGeom>
+          <a:solidFill>
+            <a:srgbClr val="E34948"/>
+          </a:solidFill>
+          <a:ln/>
+        </p:spPr>
+      </p:sp>
+      <p:sp>
+        <p:nvSpPr>
+          <p:cNvPr id="3" name="Text 1"/>
+          <p:cNvSpPr txBox="1"/>
+          <p:nvPr/>
+        </p:nvSpPr>
+        <p:spPr>
+          <a:xfrm>
+            <a:off x="822960" y="777240"/>
+            <a:ext cx="1051560" cy="1051560"/>
+          </a:xfrm>
+          <a:prstGeom prst="rect">
+            <a:avLst/>
+          </a:prstGeom>
+          <a:noFill/>
+          <a:ln/>
+        </p:spPr>
+        <p:txBody>
+          <a:bodyPr wrap="square" lIns="0" tIns="0" rIns="0" bIns="0" rtlCol="0" anchor="ctr"/>
+          <a:lstStyle/>
+          <a:p>
+            <a:pPr algn="ctr" indent="0" marL="0">
+              <a:buNone/>
+            </a:pPr>
+            <a:r>
+              <a:rPr lang="en-US" sz="3400" b="1" dirty="0">
+                <a:solidFill>
+                  <a:srgbClr val="FFFFFF"/>
+                </a:solidFill>
+                <a:latin typeface="Cambria" pitchFamily="34" charset="0"/>
+                <a:ea typeface="Cambria" pitchFamily="34" charset="-122"/>
+                <a:cs typeface="Cambria" pitchFamily="34" charset="-120"/>
+              </a:rPr>
+              <a:t>1</a:t>
+            </a:r>
+            <a:endParaRPr lang="en-US" sz="3400" dirty="0"/>
+          </a:p>
+        </p:txBody>
+      </p:sp>
+      <p:sp>
+        <p:nvSpPr>
+          <p:cNvPr id="4" name="Text 2"/>
+          <p:cNvSpPr txBox="1"/>
+          <p:nvPr/>
+        </p:nvSpPr>
+        <p:spPr>
+          <a:xfrm>
+            <a:off x="2148840" y="1024128"/>
+            <a:ext cx="7315200" cy="320040"/>
+          </a:xfrm>
+          <a:prstGeom prst="rect">
+            <a:avLst/>
+          </a:prstGeom>
+          <a:noFill/>
+          <a:ln/>
+        </p:spPr>
+        <p:txBody>
+          <a:bodyPr wrap="square" lIns="0" tIns="0" rIns="0" bIns="0" rtlCol="0" anchor="ctr"/>
+          <a:lstStyle/>
+          <a:p>
+            <a:pPr indent="0" marL="0">
+              <a:buNone/>
+            </a:pPr>
+            <a:r>
+              <a:rPr lang="en-US" sz="1300" b="1" spc="200" kern="0" dirty="0">
+                <a:solidFill>
+                  <a:srgbClr val="CADCFC"/>
+                </a:solidFill>
+                <a:latin typeface="Calibri" pitchFamily="34" charset="0"/>
+                <a:ea typeface="Calibri" pitchFamily="34" charset="-122"/>
+                <a:cs typeface="Calibri" pitchFamily="34" charset="-120"/>
+              </a:rPr>
+              <a:t>PROBLEM 1</a:t>
+            </a:r>
+            <a:endParaRPr lang="en-US" sz="1300" dirty="0"/>
+          </a:p>
+        </p:txBody>
+      </p:sp>
+      <p:sp>
+        <p:nvSpPr>
+          <p:cNvPr id="5" name="Text 3"/>
+          <p:cNvSpPr txBox="1"/>
+          <p:nvPr/>
+        </p:nvSpPr>
+        <p:spPr>
+          <a:xfrm>
+            <a:off x="822960" y="2331720"/>
+            <a:ext cx="9875520" cy="2011680"/>
+          </a:xfrm>
+          <a:prstGeom prst="rect">
+            <a:avLst/>
+          </a:prstGeom>
+          <a:noFill/>
+          <a:ln/>
+        </p:spPr>
+        <p:txBody>
+          <a:bodyPr wrap="square" lIns="0" tIns="0" rIns="0" bIns="0" rtlCol="0" anchor="t"/>
+          <a:lstStyle/>
+          <a:p>
+            <a:pPr indent="0" marL="0">
+              <a:lnSpc>
+                <a:spcPts val="4000"/>
+              </a:lnSpc>
+              <a:buNone/>
+            </a:pPr>
+            <a:r>
+              <a:rPr lang="en-US" sz="3400" b="1" dirty="0">
+                <a:solidFill>
+                  <a:srgbClr val="FFFFFF"/>
+                </a:solidFill>
+                <a:latin typeface="Cambria" pitchFamily="34" charset="0"/>
+                <a:ea typeface="Cambria" pitchFamily="34" charset="-122"/>
+                <a:cs typeface="Cambria" pitchFamily="34" charset="-120"/>
+              </a:rPr>
+              <a:t>Is quality failing consistently, or is it a specific, fixable issue?</a:t>
+            </a:r>
+            <a:endParaRPr lang="en-US" sz="3400" dirty="0"/>
+          </a:p>
+        </p:txBody>
+      </p:sp>
+      <p:sp>
+        <p:nvSpPr>
+          <p:cNvPr id="6" name="Text 4"/>
+          <p:cNvSpPr txBox="1"/>
+          <p:nvPr/>
+        </p:nvSpPr>
+        <p:spPr>
+          <a:xfrm>
+            <a:off x="822960" y="4434840"/>
+            <a:ext cx="9326880" cy="822960"/>
+          </a:xfrm>
+          <a:prstGeom prst="rect">
+            <a:avLst/>
+          </a:prstGeom>
+          <a:noFill/>
+          <a:ln/>
+        </p:spPr>
+        <p:txBody>
+          <a:bodyPr wrap="square" lIns="0" tIns="0" rIns="0" bIns="0" rtlCol="0" anchor="ctr"/>
+          <a:lstStyle/>
+          <a:p>
+            <a:pPr indent="0" marL="0">
+              <a:lnSpc>
+                <a:spcPts val="2200"/>
+              </a:lnSpc>
+              <a:buNone/>
+            </a:pPr>
+            <a:r>
+              <a:rPr lang="en-US" sz="1600" i="1" dirty="0">
+                <a:solidFill>
+                  <a:srgbClr val="CADCFC"/>
+                </a:solidFill>
+                <a:latin typeface="Calibri" pitchFamily="34" charset="0"/>
+                <a:ea typeface="Calibri" pitchFamily="34" charset="-122"/>
+                <a:cs typeface="Calibri" pitchFamily="34" charset="-120"/>
+              </a:rPr>
+              <a:t>All eight states and territories apply the same National Law.</a:t>
+            </a:r>
+            <a:endParaRPr lang="en-US" sz="1600" dirty="0"/>
+          </a:p>
+        </p:txBody>
+      </p:sp>
+      <p:sp>
+        <p:nvSpPr>
+          <p:cNvPr id="7" name="Text 5"/>
           <p:cNvSpPr txBox="1"/>
           <p:nvPr/>
         </p:nvSpPr>
@@ -6237,7 +7245,7 @@
                 <a:ea typeface="Calibri" pitchFamily="34" charset="-122"/>
                 <a:cs typeface="Calibri" pitchFamily="34" charset="-120"/>
               </a:rPr>
-              <a:t>PROBLEM 1 · CHART 2</a:t>
+              <a:t>PROBLEM 1 · CHART 1</a:t>
             </a:r>
             <a:endParaRPr lang="en-US" sz="1300" dirty="0"/>
           </a:p>
@@ -6279,7 +7287,7 @@
                 <a:ea typeface="Cambria" pitchFamily="34" charset="-122"/>
                 <a:cs typeface="Cambria" pitchFamily="34" charset="-120"/>
               </a:rPr>
-              <a:t>Family Day Care is the weakest performer nationally</a:t>
+              <a:t>Same law, a 5x compliance gap between states</a:t>
             </a:r>
             <a:endParaRPr lang="en-US" sz="2400" dirty="0"/>
           </a:p>
@@ -6287,7 +7295,7 @@
       </p:sp>
       <p:pic>
         <p:nvPicPr>
-          <p:cNvPr id="4" name="Image 0" descr="/home/user/Mart/outputs/figures/02_rating_by_service_type.png">    </p:cNvPr>
+          <p:cNvPr id="4" name="Image 0" descr="/tmp/claude-0/-home-user-Mart/76d1eb32-37a9-556d-8be9-05e0ce1a5b50/scratchpad/deck/clean_charts/01_rating_by_state.png">    </p:cNvPr>
           <p:cNvPicPr>
             <a:picLocks noChangeAspect="1"/>
           </p:cNvPicPr>
@@ -6301,8 +7309,8 @@
         </p:blipFill>
         <p:spPr>
           <a:xfrm>
-            <a:off x="2186788" y="1783080"/>
-            <a:ext cx="7818120" cy="4343400"/>
+            <a:off x="2273828" y="1783080"/>
+            <a:ext cx="7644039" cy="4343400"/>
           </a:xfrm>
           <a:prstGeom prst="rect">
             <a:avLst/>
@@ -6420,7 +7428,7 @@
                 <a:ea typeface="Calibri" pitchFamily="34" charset="-122"/>
                 <a:cs typeface="Calibri" pitchFamily="34" charset="-120"/>
               </a:rPr>
-              <a:t>PROBLEM 1 · CHART 3</a:t>
+              <a:t>PROBLEM 1 · CHART 2</a:t>
             </a:r>
             <a:endParaRPr lang="en-US" sz="1300" dirty="0"/>
           </a:p>
@@ -6462,7 +7470,7 @@
                 <a:ea typeface="Cambria" pitchFamily="34" charset="-122"/>
                 <a:cs typeface="Cambria" pitchFamily="34" charset="-120"/>
               </a:rPr>
-              <a:t>State averages hide component-level problems</a:t>
+              <a:t>Family Day Care is the weakest performer nationally</a:t>
             </a:r>
             <a:endParaRPr lang="en-US" sz="2400" dirty="0"/>
           </a:p>
@@ -6470,7 +7478,7 @@
       </p:sp>
       <p:pic>
         <p:nvPicPr>
-          <p:cNvPr id="4" name="Image 0" descr="/home/user/Mart/outputs/figures/03_quality_area_heatmap.png">    </p:cNvPr>
+          <p:cNvPr id="4" name="Image 0" descr="/tmp/claude-0/-home-user-Mart/76d1eb32-37a9-556d-8be9-05e0ce1a5b50/scratchpad/deck/clean_charts/02_rating_by_service_type.png">    </p:cNvPr>
           <p:cNvPicPr>
             <a:picLocks noChangeAspect="1"/>
           </p:cNvPicPr>
@@ -6484,8 +7492,8 @@
         </p:blipFill>
         <p:spPr>
           <a:xfrm>
-            <a:off x="1969618" y="1783080"/>
-            <a:ext cx="8252460" cy="4343400"/>
+            <a:off x="2065936" y="1783080"/>
+            <a:ext cx="8059824" cy="4343400"/>
           </a:xfrm>
           <a:prstGeom prst="rect">
             <a:avLst/>
@@ -6603,7 +7611,7 @@
                 <a:ea typeface="Calibri" pitchFamily="34" charset="-122"/>
                 <a:cs typeface="Calibri" pitchFamily="34" charset="-120"/>
               </a:rPr>
-              <a:t>PROBLEM 1 · CHART 4</a:t>
+              <a:t>PROBLEM 1 · CHART 3</a:t>
             </a:r>
             <a:endParaRPr lang="en-US" sz="1300" dirty="0"/>
           </a:p>
@@ -6645,7 +7653,7 @@
                 <a:ea typeface="Cambria" pitchFamily="34" charset="-122"/>
                 <a:cs typeface="Cambria" pitchFamily="34" charset="-120"/>
               </a:rPr>
-              <a:t>Underperformance clusters around Perth and Adelaide</a:t>
+              <a:t>State averages hide component-level problems</a:t>
             </a:r>
             <a:endParaRPr lang="en-US" sz="2400" dirty="0"/>
           </a:p>
@@ -6653,7 +7661,7 @@
       </p:sp>
       <p:pic>
         <p:nvPicPr>
-          <p:cNvPr id="4" name="Image 0" descr="/home/user/Mart/outputs/figures/04_spatial_ratings_map.png">    </p:cNvPr>
+          <p:cNvPr id="4" name="Image 0" descr="/tmp/claude-0/-home-user-Mart/76d1eb32-37a9-556d-8be9-05e0ce1a5b50/scratchpad/deck/clean_charts/03_quality_area_heatmap.png">    </p:cNvPr>
           <p:cNvPicPr>
             <a:picLocks noChangeAspect="1"/>
           </p:cNvPicPr>
@@ -6667,8 +7675,8 @@
         </p:blipFill>
         <p:spPr>
           <a:xfrm>
-            <a:off x="3652685" y="1783080"/>
-            <a:ext cx="4886325" cy="4343400"/>
+            <a:off x="1944199" y="1783080"/>
+            <a:ext cx="8303297" cy="4343400"/>
           </a:xfrm>
           <a:prstGeom prst="rect">
             <a:avLst/>
@@ -6786,7 +7794,7 @@
                 <a:ea typeface="Calibri" pitchFamily="34" charset="-122"/>
                 <a:cs typeface="Calibri" pitchFamily="34" charset="-120"/>
               </a:rPr>
-              <a:t>PROBLEM 1 · CHART 5</a:t>
+              <a:t>PROBLEM 1 · CHART 4</a:t>
             </a:r>
             <a:endParaRPr lang="en-US" sz="1300" dirty="0"/>
           </a:p>
@@ -6828,7 +7836,7 @@
                 <a:ea typeface="Cambria" pitchFamily="34" charset="-122"/>
                 <a:cs typeface="Cambria" pitchFamily="34" charset="-120"/>
               </a:rPr>
-              <a:t>Transport hurts quality — but only slightly</a:t>
+              <a:t>Underperformance clusters around Perth and Adelaide</a:t>
             </a:r>
             <a:endParaRPr lang="en-US" sz="2400" dirty="0"/>
           </a:p>
@@ -6836,7 +7844,7 @@
       </p:sp>
       <p:pic>
         <p:nvPicPr>
-          <p:cNvPr id="4" name="Image 0" descr="/home/user/Mart/outputs/figures/05_transport_vs_quality.png">    </p:cNvPr>
+          <p:cNvPr id="4" name="Image 0" descr="/tmp/claude-0/-home-user-Mart/76d1eb32-37a9-556d-8be9-05e0ce1a5b50/scratchpad/deck/clean_charts/04_spatial_ratings_map.png">    </p:cNvPr>
           <p:cNvPicPr>
             <a:picLocks noChangeAspect="1"/>
           </p:cNvPicPr>
@@ -6850,8 +7858,8 @@
         </p:blipFill>
         <p:spPr>
           <a:xfrm>
-            <a:off x="2186788" y="1783080"/>
-            <a:ext cx="7818120" cy="4343400"/>
+            <a:off x="4183537" y="1783080"/>
+            <a:ext cx="3824620" cy="4343400"/>
           </a:xfrm>
           <a:prstGeom prst="rect">
             <a:avLst/>
@@ -6918,7 +7926,7 @@
     <p:bg>
       <p:bgPr>
         <a:solidFill>
-          <a:srgbClr val="1E2761"/>
+          <a:srgbClr val="FFFFFF"/>
         </a:solidFill>
       </p:bgPr>
     </p:bg>
@@ -6938,23 +7946,42 @@
       </p:grpSpPr>
       <p:sp>
         <p:nvSpPr>
-          <p:cNvPr id="2" name="Shape 0"/>
-          <p:cNvSpPr/>
-          <p:nvPr/>
-        </p:nvSpPr>
-        <p:spPr>
-          <a:xfrm>
-            <a:off x="822960" y="777240"/>
-            <a:ext cx="1051560" cy="1051560"/>
-          </a:xfrm>
-          <a:prstGeom prst="ellipse">
-            <a:avLst/>
-          </a:prstGeom>
-          <a:solidFill>
-            <a:srgbClr val="E34948"/>
-          </a:solidFill>
-          <a:ln/>
-        </p:spPr>
+          <p:cNvPr id="2" name="Text 0"/>
+          <p:cNvSpPr txBox="1"/>
+          <p:nvPr/>
+        </p:nvSpPr>
+        <p:spPr>
+          <a:xfrm>
+            <a:off x="640080" y="457200"/>
+            <a:ext cx="7315200" cy="320040"/>
+          </a:xfrm>
+          <a:prstGeom prst="rect">
+            <a:avLst/>
+          </a:prstGeom>
+          <a:noFill/>
+          <a:ln/>
+        </p:spPr>
+        <p:txBody>
+          <a:bodyPr wrap="square" lIns="0" tIns="0" rIns="0" bIns="0" rtlCol="0" anchor="ctr"/>
+          <a:lstStyle/>
+          <a:p>
+            <a:pPr indent="0" marL="0">
+              <a:buNone/>
+            </a:pPr>
+            <a:r>
+              <a:rPr lang="en-US" sz="1300" b="1" spc="200" kern="0" dirty="0">
+                <a:solidFill>
+                  <a:srgbClr val="E34948"/>
+                </a:solidFill>
+                <a:latin typeface="Calibri" pitchFamily="34" charset="0"/>
+                <a:ea typeface="Calibri" pitchFamily="34" charset="-122"/>
+                <a:cs typeface="Calibri" pitchFamily="34" charset="-120"/>
+              </a:rPr>
+              <a:t>PROBLEM 1 · CHART 5</a:t>
+            </a:r>
+            <a:endParaRPr lang="en-US" sz="1300" dirty="0"/>
+          </a:p>
+        </p:txBody>
       </p:sp>
       <p:sp>
         <p:nvSpPr>
@@ -6964,163 +7991,74 @@
         </p:nvSpPr>
         <p:spPr>
           <a:xfrm>
-            <a:off x="822960" y="777240"/>
-            <a:ext cx="1051560" cy="1051560"/>
-          </a:xfrm>
-          <a:prstGeom prst="rect">
-            <a:avLst/>
-          </a:prstGeom>
-          <a:noFill/>
-          <a:ln/>
-        </p:spPr>
-        <p:txBody>
-          <a:bodyPr wrap="square" lIns="0" tIns="0" rIns="0" bIns="0" rtlCol="0" anchor="ctr"/>
-          <a:lstStyle/>
-          <a:p>
-            <a:pPr algn="ctr" indent="0" marL="0">
-              <a:buNone/>
-            </a:pPr>
-            <a:r>
-              <a:rPr lang="en-US" sz="3400" b="1" dirty="0">
-                <a:solidFill>
-                  <a:srgbClr val="FFFFFF"/>
+            <a:off x="640080" y="731520"/>
+            <a:ext cx="10911535" cy="960120"/>
+          </a:xfrm>
+          <a:prstGeom prst="rect">
+            <a:avLst/>
+          </a:prstGeom>
+          <a:noFill/>
+          <a:ln/>
+        </p:spPr>
+        <p:txBody>
+          <a:bodyPr wrap="square" lIns="0" tIns="0" rIns="0" bIns="0" rtlCol="0" anchor="t"/>
+          <a:lstStyle/>
+          <a:p>
+            <a:pPr indent="0" marL="0">
+              <a:lnSpc>
+                <a:spcPts val="2800"/>
+              </a:lnSpc>
+              <a:buNone/>
+            </a:pPr>
+            <a:r>
+              <a:rPr lang="en-US" sz="2400" b="1" dirty="0">
+                <a:solidFill>
+                  <a:srgbClr val="1E2761"/>
                 </a:solidFill>
                 <a:latin typeface="Cambria" pitchFamily="34" charset="0"/>
                 <a:ea typeface="Cambria" pitchFamily="34" charset="-122"/>
                 <a:cs typeface="Cambria" pitchFamily="34" charset="-120"/>
               </a:rPr>
-              <a:t>2</a:t>
-            </a:r>
-            <a:endParaRPr lang="en-US" sz="3400" dirty="0"/>
-          </a:p>
-        </p:txBody>
-      </p:sp>
-      <p:sp>
-        <p:nvSpPr>
-          <p:cNvPr id="4" name="Text 2"/>
-          <p:cNvSpPr txBox="1"/>
-          <p:nvPr/>
-        </p:nvSpPr>
-        <p:spPr>
-          <a:xfrm>
-            <a:off x="2148840" y="1024128"/>
-            <a:ext cx="7315200" cy="320040"/>
-          </a:xfrm>
-          <a:prstGeom prst="rect">
-            <a:avLst/>
-          </a:prstGeom>
-          <a:noFill/>
-          <a:ln/>
-        </p:spPr>
-        <p:txBody>
-          <a:bodyPr wrap="square" lIns="0" tIns="0" rIns="0" bIns="0" rtlCol="0" anchor="ctr"/>
-          <a:lstStyle/>
-          <a:p>
-            <a:pPr indent="0" marL="0">
-              <a:buNone/>
-            </a:pPr>
-            <a:r>
-              <a:rPr lang="en-US" sz="1300" b="1" spc="200" kern="0" dirty="0">
-                <a:solidFill>
-                  <a:srgbClr val="CADCFC"/>
-                </a:solidFill>
-                <a:latin typeface="Calibri" pitchFamily="34" charset="0"/>
-                <a:ea typeface="Calibri" pitchFamily="34" charset="-122"/>
-                <a:cs typeface="Calibri" pitchFamily="34" charset="-120"/>
-              </a:rPr>
-              <a:t>PROBLEM 2</a:t>
-            </a:r>
-            <a:endParaRPr lang="en-US" sz="1300" dirty="0"/>
-          </a:p>
-        </p:txBody>
-      </p:sp>
-      <p:sp>
-        <p:nvSpPr>
-          <p:cNvPr id="5" name="Text 3"/>
-          <p:cNvSpPr txBox="1"/>
-          <p:nvPr/>
-        </p:nvSpPr>
-        <p:spPr>
-          <a:xfrm>
-            <a:off x="822960" y="2331720"/>
-            <a:ext cx="9875520" cy="2011680"/>
-          </a:xfrm>
-          <a:prstGeom prst="rect">
-            <a:avLst/>
-          </a:prstGeom>
-          <a:noFill/>
-          <a:ln/>
-        </p:spPr>
-        <p:txBody>
-          <a:bodyPr wrap="square" lIns="0" tIns="0" rIns="0" bIns="0" rtlCol="0" anchor="t"/>
-          <a:lstStyle/>
-          <a:p>
-            <a:pPr indent="0" marL="0">
-              <a:lnSpc>
-                <a:spcPts val="4000"/>
-              </a:lnSpc>
-              <a:buNone/>
-            </a:pPr>
-            <a:r>
-              <a:rPr lang="en-US" sz="3400" b="1" dirty="0">
-                <a:solidFill>
-                  <a:srgbClr val="FFFFFF"/>
-                </a:solidFill>
-                <a:latin typeface="Cambria" pitchFamily="34" charset="0"/>
-                <a:ea typeface="Cambria" pitchFamily="34" charset="-122"/>
-                <a:cs typeface="Cambria" pitchFamily="34" charset="-120"/>
-              </a:rPr>
-              <a:t>Are families structurally cut off from services — and where worst?</a:t>
-            </a:r>
-            <a:endParaRPr lang="en-US" sz="3400" dirty="0"/>
-          </a:p>
-        </p:txBody>
-      </p:sp>
-      <p:sp>
-        <p:nvSpPr>
-          <p:cNvPr id="6" name="Text 4"/>
-          <p:cNvSpPr txBox="1"/>
-          <p:nvPr/>
-        </p:nvSpPr>
-        <p:spPr>
-          <a:xfrm>
-            <a:off x="822960" y="4434840"/>
-            <a:ext cx="9326880" cy="822960"/>
-          </a:xfrm>
-          <a:prstGeom prst="rect">
-            <a:avLst/>
-          </a:prstGeom>
-          <a:noFill/>
-          <a:ln/>
-        </p:spPr>
-        <p:txBody>
-          <a:bodyPr wrap="square" lIns="0" tIns="0" rIns="0" bIns="0" rtlCol="0" anchor="ctr"/>
-          <a:lstStyle/>
-          <a:p>
-            <a:pPr indent="0" marL="0">
-              <a:lnSpc>
-                <a:spcPts val="2200"/>
-              </a:lnSpc>
-              <a:buNone/>
-            </a:pPr>
-            <a:r>
-              <a:rPr lang="en-US" sz="1600" i="1" dirty="0">
-                <a:solidFill>
-                  <a:srgbClr val="CADCFC"/>
-                </a:solidFill>
-                <a:latin typeface="Calibri" pitchFamily="34" charset="0"/>
-                <a:ea typeface="Calibri" pitchFamily="34" charset="-122"/>
-                <a:cs typeface="Calibri" pitchFamily="34" charset="-120"/>
-              </a:rPr>
-              <a:t>Four assignment requirements, four charts built to prove a claim — plus one gut-check chart.</a:t>
-            </a:r>
-            <a:endParaRPr lang="en-US" sz="1600" dirty="0"/>
-          </a:p>
-        </p:txBody>
-      </p:sp>
-      <p:sp>
-        <p:nvSpPr>
-          <p:cNvPr id="7" name="Text 5"/>
+              <a:t>Transport hurts quality — but only slightly</a:t>
+            </a:r>
+            <a:endParaRPr lang="en-US" sz="2400" dirty="0"/>
+          </a:p>
+        </p:txBody>
+      </p:sp>
+      <p:pic>
+        <p:nvPicPr>
+          <p:cNvPr id="4" name="Image 0" descr="/tmp/claude-0/-home-user-Mart/76d1eb32-37a9-556d-8be9-05e0ce1a5b50/scratchpad/deck/clean_charts/05_transport_vs_quality.png">    </p:cNvPr>
+          <p:cNvPicPr>
+            <a:picLocks noChangeAspect="1"/>
+          </p:cNvPicPr>
+          <p:nvPr/>
+        </p:nvPicPr>
+        <p:blipFill>
+          <a:blip r:embed="rId1"/>
+          <a:stretch>
+            <a:fillRect/>
+          </a:stretch>
+        </p:blipFill>
+        <p:spPr>
+          <a:xfrm>
+            <a:off x="2164627" y="1783080"/>
+            <a:ext cx="7862440" cy="4343400"/>
+          </a:xfrm>
+          <a:prstGeom prst="rect">
+            <a:avLst/>
+          </a:prstGeom>
+          <a:effectLst>
+            <a:outerShdw sx="100000" sy="100000" kx="0" ky="0" algn="bl" rotWithShape="0" blurRad="101600" dist="38100" dir="5400000">
+              <a:srgbClr val="0F1533">
+                <a:alpha val="35000"/>
+              </a:srgbClr>
+            </a:outerShdw>
+          </a:effectLst>
+        </p:spPr>
+      </p:pic>
+      <p:sp>
+        <p:nvSpPr>
+          <p:cNvPr id="5" name="Text 2"/>
           <p:cNvSpPr txBox="1"/>
           <p:nvPr/>
         </p:nvSpPr>

</xml_diff>